<commit_message>
New feature: hyperparameters fine tuning
</commit_message>
<xml_diff>
--- a/Gsasrec.pptx
+++ b/Gsasrec.pptx
@@ -15,6 +15,9 @@
     <p:sldId id="262" r:id="rId9"/>
     <p:sldId id="264" r:id="rId10"/>
     <p:sldId id="265" r:id="rId11"/>
+    <p:sldId id="266" r:id="rId12"/>
+    <p:sldId id="267" r:id="rId13"/>
+    <p:sldId id="268" r:id="rId14"/>
   </p:sldIdLst>
   <p:sldSz cx="12192000" cy="6858000"/>
   <p:notesSz cx="6858000" cy="9144000"/>
@@ -6143,7 +6146,7 @@
           <a:p>
             <a:fld id="{842CECD3-3569-4D6E-AA1B-67789CA6B4B3}" type="datetimeFigureOut">
               <a:rPr lang="en-GB" smtClean="0"/>
-              <a:t>25/04/2026</a:t>
+              <a:t>30/04/2026</a:t>
             </a:fld>
             <a:endParaRPr lang="en-GB"/>
           </a:p>
@@ -6579,7 +6582,7 @@
           <a:p>
             <a:fld id="{842CECD3-3569-4D6E-AA1B-67789CA6B4B3}" type="datetimeFigureOut">
               <a:rPr lang="en-GB" smtClean="0"/>
-              <a:t>25/04/2026</a:t>
+              <a:t>30/04/2026</a:t>
             </a:fld>
             <a:endParaRPr lang="en-GB"/>
           </a:p>
@@ -6829,7 +6832,7 @@
           <a:p>
             <a:fld id="{842CECD3-3569-4D6E-AA1B-67789CA6B4B3}" type="datetimeFigureOut">
               <a:rPr lang="en-GB" smtClean="0"/>
-              <a:t>25/04/2026</a:t>
+              <a:t>30/04/2026</a:t>
             </a:fld>
             <a:endParaRPr lang="en-GB"/>
           </a:p>
@@ -7137,7 +7140,7 @@
           <a:p>
             <a:fld id="{842CECD3-3569-4D6E-AA1B-67789CA6B4B3}" type="datetimeFigureOut">
               <a:rPr lang="en-GB" smtClean="0"/>
-              <a:t>25/04/2026</a:t>
+              <a:t>30/04/2026</a:t>
             </a:fld>
             <a:endParaRPr lang="en-GB"/>
           </a:p>
@@ -7455,7 +7458,7 @@
           <a:p>
             <a:fld id="{842CECD3-3569-4D6E-AA1B-67789CA6B4B3}" type="datetimeFigureOut">
               <a:rPr lang="en-GB" smtClean="0"/>
-              <a:t>25/04/2026</a:t>
+              <a:t>30/04/2026</a:t>
             </a:fld>
             <a:endParaRPr lang="en-GB"/>
           </a:p>
@@ -7757,7 +7760,7 @@
           <a:p>
             <a:fld id="{842CECD3-3569-4D6E-AA1B-67789CA6B4B3}" type="datetimeFigureOut">
               <a:rPr lang="en-GB" smtClean="0"/>
-              <a:t>25/04/2026</a:t>
+              <a:t>30/04/2026</a:t>
             </a:fld>
             <a:endParaRPr lang="en-GB"/>
           </a:p>
@@ -8124,7 +8127,7 @@
           <a:p>
             <a:fld id="{842CECD3-3569-4D6E-AA1B-67789CA6B4B3}" type="datetimeFigureOut">
               <a:rPr lang="en-GB" smtClean="0"/>
-              <a:t>25/04/2026</a:t>
+              <a:t>30/04/2026</a:t>
             </a:fld>
             <a:endParaRPr lang="en-GB"/>
           </a:p>
@@ -8298,7 +8301,7 @@
           <a:p>
             <a:fld id="{842CECD3-3569-4D6E-AA1B-67789CA6B4B3}" type="datetimeFigureOut">
               <a:rPr lang="en-GB" smtClean="0"/>
-              <a:t>25/04/2026</a:t>
+              <a:t>30/04/2026</a:t>
             </a:fld>
             <a:endParaRPr lang="en-GB"/>
           </a:p>
@@ -8478,7 +8481,7 @@
           <a:p>
             <a:fld id="{842CECD3-3569-4D6E-AA1B-67789CA6B4B3}" type="datetimeFigureOut">
               <a:rPr lang="en-GB" smtClean="0"/>
-              <a:t>25/04/2026</a:t>
+              <a:t>30/04/2026</a:t>
             </a:fld>
             <a:endParaRPr lang="en-GB"/>
           </a:p>
@@ -8648,7 +8651,7 @@
           <a:p>
             <a:fld id="{842CECD3-3569-4D6E-AA1B-67789CA6B4B3}" type="datetimeFigureOut">
               <a:rPr lang="en-GB" smtClean="0"/>
-              <a:t>25/04/2026</a:t>
+              <a:t>30/04/2026</a:t>
             </a:fld>
             <a:endParaRPr lang="en-GB"/>
           </a:p>
@@ -8898,7 +8901,7 @@
           <a:p>
             <a:fld id="{842CECD3-3569-4D6E-AA1B-67789CA6B4B3}" type="datetimeFigureOut">
               <a:rPr lang="en-GB" smtClean="0"/>
-              <a:t>25/04/2026</a:t>
+              <a:t>30/04/2026</a:t>
             </a:fld>
             <a:endParaRPr lang="en-GB"/>
           </a:p>
@@ -9134,7 +9137,7 @@
           <a:p>
             <a:fld id="{842CECD3-3569-4D6E-AA1B-67789CA6B4B3}" type="datetimeFigureOut">
               <a:rPr lang="en-GB" smtClean="0"/>
-              <a:t>25/04/2026</a:t>
+              <a:t>30/04/2026</a:t>
             </a:fld>
             <a:endParaRPr lang="en-GB"/>
           </a:p>
@@ -9516,7 +9519,7 @@
           <a:p>
             <a:fld id="{842CECD3-3569-4D6E-AA1B-67789CA6B4B3}" type="datetimeFigureOut">
               <a:rPr lang="en-GB" smtClean="0"/>
-              <a:t>25/04/2026</a:t>
+              <a:t>30/04/2026</a:t>
             </a:fld>
             <a:endParaRPr lang="en-GB"/>
           </a:p>
@@ -9634,7 +9637,7 @@
           <a:p>
             <a:fld id="{842CECD3-3569-4D6E-AA1B-67789CA6B4B3}" type="datetimeFigureOut">
               <a:rPr lang="en-GB" smtClean="0"/>
-              <a:t>25/04/2026</a:t>
+              <a:t>30/04/2026</a:t>
             </a:fld>
             <a:endParaRPr lang="en-GB"/>
           </a:p>
@@ -9729,7 +9732,7 @@
           <a:p>
             <a:fld id="{842CECD3-3569-4D6E-AA1B-67789CA6B4B3}" type="datetimeFigureOut">
               <a:rPr lang="en-GB" smtClean="0"/>
-              <a:t>25/04/2026</a:t>
+              <a:t>30/04/2026</a:t>
             </a:fld>
             <a:endParaRPr lang="en-GB"/>
           </a:p>
@@ -9984,7 +9987,7 @@
           <a:p>
             <a:fld id="{842CECD3-3569-4D6E-AA1B-67789CA6B4B3}" type="datetimeFigureOut">
               <a:rPr lang="en-GB" smtClean="0"/>
-              <a:t>25/04/2026</a:t>
+              <a:t>30/04/2026</a:t>
             </a:fld>
             <a:endParaRPr lang="en-GB"/>
           </a:p>
@@ -10267,7 +10270,7 @@
           <a:p>
             <a:fld id="{842CECD3-3569-4D6E-AA1B-67789CA6B4B3}" type="datetimeFigureOut">
               <a:rPr lang="en-GB" smtClean="0"/>
-              <a:t>25/04/2026</a:t>
+              <a:t>30/04/2026</a:t>
             </a:fld>
             <a:endParaRPr lang="en-GB"/>
           </a:p>
@@ -10673,7 +10676,7 @@
           <a:p>
             <a:fld id="{842CECD3-3569-4D6E-AA1B-67789CA6B4B3}" type="datetimeFigureOut">
               <a:rPr lang="en-GB" smtClean="0"/>
-              <a:t>25/04/2026</a:t>
+              <a:t>30/04/2026</a:t>
             </a:fld>
             <a:endParaRPr lang="en-GB"/>
           </a:p>
@@ -11581,6 +11584,459 @@
 </p:sld>
 </file>
 
+<file path=ppt/slides/slide11.xml><?xml version="1.0" encoding="utf-8"?>
+<p:sld xmlns:a="http://schemas.openxmlformats.org/drawingml/2006/main" xmlns:r="http://schemas.openxmlformats.org/officeDocument/2006/relationships" xmlns:p="http://schemas.openxmlformats.org/presentationml/2006/main">
+  <p:cSld>
+    <p:spTree>
+      <p:nvGrpSpPr>
+        <p:cNvPr id="1" name=""/>
+        <p:cNvGrpSpPr/>
+        <p:nvPr/>
+      </p:nvGrpSpPr>
+      <p:grpSpPr>
+        <a:xfrm>
+          <a:off x="0" y="0"/>
+          <a:ext cx="0" cy="0"/>
+          <a:chOff x="0" y="0"/>
+          <a:chExt cx="0" cy="0"/>
+        </a:xfrm>
+      </p:grpSpPr>
+      <p:sp>
+        <p:nvSpPr>
+          <p:cNvPr id="2" name="Title 1">
+            <a:extLst>
+              <a:ext uri="{FF2B5EF4-FFF2-40B4-BE49-F238E27FC236}">
+                <a16:creationId xmlns:a16="http://schemas.microsoft.com/office/drawing/2014/main" id="{BCC950C5-BD42-D313-9BBD-40EBD1243637}"/>
+              </a:ext>
+            </a:extLst>
+          </p:cNvPr>
+          <p:cNvSpPr>
+            <a:spLocks noGrp="1"/>
+          </p:cNvSpPr>
+          <p:nvPr>
+            <p:ph type="title"/>
+          </p:nvPr>
+        </p:nvSpPr>
+        <p:spPr/>
+        <p:txBody>
+          <a:bodyPr/>
+          <a:lstStyle/>
+          <a:p>
+            <a:r>
+              <a:rPr lang="it-IT" dirty="0"/>
+              <a:t>OTTIMIZZAZIONE DEGLI IPERPARAMETRI</a:t>
+            </a:r>
+            <a:endParaRPr lang="en-GB" dirty="0"/>
+          </a:p>
+        </p:txBody>
+      </p:sp>
+      <p:sp>
+        <p:nvSpPr>
+          <p:cNvPr id="3" name="Content Placeholder 2">
+            <a:extLst>
+              <a:ext uri="{FF2B5EF4-FFF2-40B4-BE49-F238E27FC236}">
+                <a16:creationId xmlns:a16="http://schemas.microsoft.com/office/drawing/2014/main" id="{F83D878F-729D-FE9B-1482-69E151CB938C}"/>
+              </a:ext>
+            </a:extLst>
+          </p:cNvPr>
+          <p:cNvSpPr>
+            <a:spLocks noGrp="1"/>
+          </p:cNvSpPr>
+          <p:nvPr>
+            <p:ph idx="1"/>
+          </p:nvPr>
+        </p:nvSpPr>
+        <p:spPr/>
+        <p:txBody>
+          <a:bodyPr/>
+          <a:lstStyle/>
+          <a:p>
+            <a:pPr marL="0" indent="0">
+              <a:buNone/>
+            </a:pPr>
+            <a:r>
+              <a:rPr lang="it-IT" dirty="0">
+                <a:solidFill>
+                  <a:schemeClr val="tx1"/>
+                </a:solidFill>
+              </a:rPr>
+              <a:t>Per poter verificare quale sia la miglior combinazione di </a:t>
+            </a:r>
+            <a:r>
+              <a:rPr lang="it-IT" dirty="0" err="1">
+                <a:solidFill>
+                  <a:schemeClr val="tx1"/>
+                </a:solidFill>
+              </a:rPr>
+              <a:t>iperparametri</a:t>
+            </a:r>
+            <a:r>
+              <a:rPr lang="it-IT" dirty="0">
+                <a:solidFill>
+                  <a:schemeClr val="tx1"/>
+                </a:solidFill>
+              </a:rPr>
+              <a:t>:</a:t>
+            </a:r>
+          </a:p>
+          <a:p>
+            <a:r>
+              <a:rPr lang="it-IT" dirty="0">
+                <a:solidFill>
+                  <a:schemeClr val="tx1"/>
+                </a:solidFill>
+              </a:rPr>
+              <a:t>È stata utilizzata NDCG@10 come metrica di valutazione.</a:t>
+            </a:r>
+          </a:p>
+          <a:p>
+            <a:r>
+              <a:rPr lang="it-IT" dirty="0">
+                <a:solidFill>
+                  <a:schemeClr val="tx1"/>
+                </a:solidFill>
+              </a:rPr>
+              <a:t>È stato creato fine_tuning.py che si appoggia a </a:t>
+            </a:r>
+            <a:r>
+              <a:rPr lang="it-IT" dirty="0" err="1">
+                <a:solidFill>
+                  <a:schemeClr val="tx1"/>
+                </a:solidFill>
+              </a:rPr>
+              <a:t>optuna</a:t>
+            </a:r>
+            <a:r>
+              <a:rPr lang="it-IT" dirty="0">
+                <a:solidFill>
+                  <a:schemeClr val="tx1"/>
+                </a:solidFill>
+              </a:rPr>
+              <a:t>.</a:t>
+            </a:r>
+          </a:p>
+          <a:p>
+            <a:r>
+              <a:rPr lang="it-IT" dirty="0">
+                <a:solidFill>
+                  <a:schemeClr val="tx1"/>
+                </a:solidFill>
+              </a:rPr>
+              <a:t>È stato modificato </a:t>
+            </a:r>
+            <a:r>
+              <a:rPr lang="it-IT" dirty="0" err="1">
+                <a:solidFill>
+                  <a:schemeClr val="tx1"/>
+                </a:solidFill>
+              </a:rPr>
+              <a:t>train_gsasrec</a:t>
+            </a:r>
+            <a:r>
+              <a:rPr lang="it-IT" dirty="0">
+                <a:solidFill>
+                  <a:schemeClr val="tx1"/>
+                </a:solidFill>
+              </a:rPr>
+              <a:t> per poter esser richiamato ogni volta fosse necessario provare una combinazione.</a:t>
+            </a:r>
+          </a:p>
+        </p:txBody>
+      </p:sp>
+    </p:spTree>
+    <p:extLst>
+      <p:ext uri="{BB962C8B-B14F-4D97-AF65-F5344CB8AC3E}">
+        <p14:creationId xmlns:p14="http://schemas.microsoft.com/office/powerpoint/2010/main" val="777409367"/>
+      </p:ext>
+    </p:extLst>
+  </p:cSld>
+  <p:clrMapOvr>
+    <a:masterClrMapping/>
+  </p:clrMapOvr>
+</p:sld>
+</file>
+
+<file path=ppt/slides/slide12.xml><?xml version="1.0" encoding="utf-8"?>
+<p:sld xmlns:a="http://schemas.openxmlformats.org/drawingml/2006/main" xmlns:r="http://schemas.openxmlformats.org/officeDocument/2006/relationships" xmlns:p="http://schemas.openxmlformats.org/presentationml/2006/main">
+  <p:cSld>
+    <p:spTree>
+      <p:nvGrpSpPr>
+        <p:cNvPr id="1" name=""/>
+        <p:cNvGrpSpPr/>
+        <p:nvPr/>
+      </p:nvGrpSpPr>
+      <p:grpSpPr>
+        <a:xfrm>
+          <a:off x="0" y="0"/>
+          <a:ext cx="0" cy="0"/>
+          <a:chOff x="0" y="0"/>
+          <a:chExt cx="0" cy="0"/>
+        </a:xfrm>
+      </p:grpSpPr>
+      <p:sp>
+        <p:nvSpPr>
+          <p:cNvPr id="2" name="Title 1">
+            <a:extLst>
+              <a:ext uri="{FF2B5EF4-FFF2-40B4-BE49-F238E27FC236}">
+                <a16:creationId xmlns:a16="http://schemas.microsoft.com/office/drawing/2014/main" id="{F17F82B6-D018-2AD1-80FD-CD347D5659C8}"/>
+              </a:ext>
+            </a:extLst>
+          </p:cNvPr>
+          <p:cNvSpPr>
+            <a:spLocks noGrp="1"/>
+          </p:cNvSpPr>
+          <p:nvPr>
+            <p:ph type="title"/>
+          </p:nvPr>
+        </p:nvSpPr>
+        <p:spPr/>
+        <p:txBody>
+          <a:bodyPr/>
+          <a:lstStyle/>
+          <a:p>
+            <a:r>
+              <a:rPr lang="it-IT" dirty="0"/>
+              <a:t>Fine_tuning.py</a:t>
+            </a:r>
+            <a:endParaRPr lang="en-GB" dirty="0"/>
+          </a:p>
+        </p:txBody>
+      </p:sp>
+      <p:sp>
+        <p:nvSpPr>
+          <p:cNvPr id="3" name="Content Placeholder 2">
+            <a:extLst>
+              <a:ext uri="{FF2B5EF4-FFF2-40B4-BE49-F238E27FC236}">
+                <a16:creationId xmlns:a16="http://schemas.microsoft.com/office/drawing/2014/main" id="{CF576F9B-23DA-306F-F2F1-63A1205B3C6B}"/>
+              </a:ext>
+            </a:extLst>
+          </p:cNvPr>
+          <p:cNvSpPr>
+            <a:spLocks noGrp="1"/>
+          </p:cNvSpPr>
+          <p:nvPr>
+            <p:ph idx="1"/>
+          </p:nvPr>
+        </p:nvSpPr>
+        <p:spPr/>
+        <p:txBody>
+          <a:bodyPr/>
+          <a:lstStyle/>
+          <a:p>
+            <a:pPr marL="0" indent="0">
+              <a:buNone/>
+            </a:pPr>
+            <a:r>
+              <a:rPr lang="it-IT" dirty="0">
+                <a:solidFill>
+                  <a:schemeClr val="tx1"/>
+                </a:solidFill>
+              </a:rPr>
+              <a:t>Questo file va a creare e poi ogni volta modificare config_optuna.py da passare tramite linea di comando per poter specificare ogni volta i parametri. </a:t>
+            </a:r>
+            <a:r>
+              <a:rPr lang="it-IT" dirty="0" err="1">
+                <a:solidFill>
+                  <a:schemeClr val="tx1"/>
+                </a:solidFill>
+              </a:rPr>
+              <a:t>Optuna</a:t>
+            </a:r>
+            <a:r>
+              <a:rPr lang="it-IT" dirty="0">
+                <a:solidFill>
+                  <a:schemeClr val="tx1"/>
+                </a:solidFill>
+              </a:rPr>
+              <a:t> si basa sull’ottimizzazione </a:t>
+            </a:r>
+            <a:r>
+              <a:rPr lang="it-IT" dirty="0" err="1">
+                <a:solidFill>
+                  <a:schemeClr val="tx1"/>
+                </a:solidFill>
+              </a:rPr>
+              <a:t>Bayesiana</a:t>
+            </a:r>
+            <a:r>
+              <a:rPr lang="it-IT" dirty="0">
+                <a:solidFill>
+                  <a:schemeClr val="tx1"/>
+                </a:solidFill>
+              </a:rPr>
+              <a:t>, per ogni tentativo prevede quali potrebbero essere i parametri migliori per il tentativo successivo. Scelto perché:</a:t>
+            </a:r>
+          </a:p>
+          <a:p>
+            <a:r>
+              <a:rPr lang="it-IT" dirty="0">
+                <a:solidFill>
+                  <a:schemeClr val="tx1"/>
+                </a:solidFill>
+              </a:rPr>
+              <a:t>Impara dal passato.</a:t>
+            </a:r>
+          </a:p>
+          <a:p>
+            <a:r>
+              <a:rPr lang="it-IT" dirty="0">
+                <a:solidFill>
+                  <a:schemeClr val="tx1"/>
+                </a:solidFill>
+              </a:rPr>
+              <a:t>Fa risparmiare tempo, utile soprattutto in contesti di training lunghi.</a:t>
+            </a:r>
+          </a:p>
+          <a:p>
+            <a:r>
+              <a:rPr lang="it-IT" dirty="0">
+                <a:solidFill>
+                  <a:schemeClr val="tx1"/>
+                </a:solidFill>
+              </a:rPr>
+              <a:t>Framework </a:t>
+            </a:r>
+            <a:r>
+              <a:rPr lang="it-IT" dirty="0" err="1">
+                <a:solidFill>
+                  <a:schemeClr val="tx1"/>
+                </a:solidFill>
+              </a:rPr>
+              <a:t>agnostic</a:t>
+            </a:r>
+            <a:r>
+              <a:rPr lang="it-IT" dirty="0">
+                <a:solidFill>
+                  <a:schemeClr val="tx1"/>
+                </a:solidFill>
+              </a:rPr>
+              <a:t> (a differenza di </a:t>
+            </a:r>
+            <a:r>
+              <a:rPr lang="it-IT" dirty="0" err="1">
+                <a:solidFill>
+                  <a:schemeClr val="tx1"/>
+                </a:solidFill>
+              </a:rPr>
+              <a:t>GridSearchCV</a:t>
+            </a:r>
+            <a:r>
+              <a:rPr lang="it-IT" dirty="0">
+                <a:solidFill>
+                  <a:schemeClr val="tx1"/>
+                </a:solidFill>
+              </a:rPr>
+              <a:t>)</a:t>
+            </a:r>
+            <a:endParaRPr lang="en-GB" dirty="0">
+              <a:solidFill>
+                <a:schemeClr val="tx1"/>
+              </a:solidFill>
+            </a:endParaRPr>
+          </a:p>
+        </p:txBody>
+      </p:sp>
+    </p:spTree>
+    <p:extLst>
+      <p:ext uri="{BB962C8B-B14F-4D97-AF65-F5344CB8AC3E}">
+        <p14:creationId xmlns:p14="http://schemas.microsoft.com/office/powerpoint/2010/main" val="1553646564"/>
+      </p:ext>
+    </p:extLst>
+  </p:cSld>
+  <p:clrMapOvr>
+    <a:masterClrMapping/>
+  </p:clrMapOvr>
+</p:sld>
+</file>
+
+<file path=ppt/slides/slide13.xml><?xml version="1.0" encoding="utf-8"?>
+<p:sld xmlns:a="http://schemas.openxmlformats.org/drawingml/2006/main" xmlns:r="http://schemas.openxmlformats.org/officeDocument/2006/relationships" xmlns:p="http://schemas.openxmlformats.org/presentationml/2006/main">
+  <p:cSld>
+    <p:spTree>
+      <p:nvGrpSpPr>
+        <p:cNvPr id="1" name=""/>
+        <p:cNvGrpSpPr/>
+        <p:nvPr/>
+      </p:nvGrpSpPr>
+      <p:grpSpPr>
+        <a:xfrm>
+          <a:off x="0" y="0"/>
+          <a:ext cx="0" cy="0"/>
+          <a:chOff x="0" y="0"/>
+          <a:chExt cx="0" cy="0"/>
+        </a:xfrm>
+      </p:grpSpPr>
+      <p:sp>
+        <p:nvSpPr>
+          <p:cNvPr id="2" name="Title 1">
+            <a:extLst>
+              <a:ext uri="{FF2B5EF4-FFF2-40B4-BE49-F238E27FC236}">
+                <a16:creationId xmlns:a16="http://schemas.microsoft.com/office/drawing/2014/main" id="{D106D4DC-3F3E-33DC-2BDE-8023342EDA8A}"/>
+              </a:ext>
+            </a:extLst>
+          </p:cNvPr>
+          <p:cNvSpPr>
+            <a:spLocks noGrp="1"/>
+          </p:cNvSpPr>
+          <p:nvPr>
+            <p:ph type="title"/>
+          </p:nvPr>
+        </p:nvSpPr>
+        <p:spPr/>
+        <p:txBody>
+          <a:bodyPr/>
+          <a:lstStyle/>
+          <a:p>
+            <a:r>
+              <a:rPr lang="it-IT" dirty="0"/>
+              <a:t>Range degli </a:t>
+            </a:r>
+            <a:r>
+              <a:rPr lang="it-IT" dirty="0" err="1"/>
+              <a:t>iperparametri</a:t>
+            </a:r>
+            <a:endParaRPr lang="en-GB" dirty="0"/>
+          </a:p>
+        </p:txBody>
+      </p:sp>
+      <p:sp>
+        <p:nvSpPr>
+          <p:cNvPr id="3" name="Content Placeholder 2">
+            <a:extLst>
+              <a:ext uri="{FF2B5EF4-FFF2-40B4-BE49-F238E27FC236}">
+                <a16:creationId xmlns:a16="http://schemas.microsoft.com/office/drawing/2014/main" id="{346D75B8-7ECB-AD6F-8118-0610B93CBFD6}"/>
+              </a:ext>
+            </a:extLst>
+          </p:cNvPr>
+          <p:cNvSpPr>
+            <a:spLocks noGrp="1"/>
+          </p:cNvSpPr>
+          <p:nvPr>
+            <p:ph idx="1"/>
+          </p:nvPr>
+        </p:nvSpPr>
+        <p:spPr/>
+        <p:txBody>
+          <a:bodyPr/>
+          <a:lstStyle/>
+          <a:p>
+            <a:endParaRPr lang="en-GB"/>
+          </a:p>
+        </p:txBody>
+      </p:sp>
+    </p:spTree>
+    <p:extLst>
+      <p:ext uri="{BB962C8B-B14F-4D97-AF65-F5344CB8AC3E}">
+        <p14:creationId xmlns:p14="http://schemas.microsoft.com/office/powerpoint/2010/main" val="1824266746"/>
+      </p:ext>
+    </p:extLst>
+  </p:cSld>
+  <p:clrMapOvr>
+    <a:masterClrMapping/>
+  </p:clrMapOvr>
+</p:sld>
+</file>
+
 <file path=ppt/slides/slide2.xml><?xml version="1.0" encoding="utf-8"?>
 <p:sld xmlns:a="http://schemas.openxmlformats.org/drawingml/2006/main" xmlns:r="http://schemas.openxmlformats.org/officeDocument/2006/relationships" xmlns:p="http://schemas.openxmlformats.org/presentationml/2006/main">
   <p:cSld>

</xml_diff>

<commit_message>
Update: creating a local endpoint with FastAPI to test the model
</commit_message>
<xml_diff>
--- a/Gsasrec.pptx
+++ b/Gsasrec.pptx
@@ -18,6 +18,8 @@
     <p:sldId id="266" r:id="rId12"/>
     <p:sldId id="267" r:id="rId13"/>
     <p:sldId id="268" r:id="rId14"/>
+    <p:sldId id="269" r:id="rId15"/>
+    <p:sldId id="270" r:id="rId16"/>
   </p:sldIdLst>
   <p:sldSz cx="12192000" cy="6858000"/>
   <p:notesSz cx="6858000" cy="9144000"/>
@@ -6146,7 +6148,7 @@
           <a:p>
             <a:fld id="{842CECD3-3569-4D6E-AA1B-67789CA6B4B3}" type="datetimeFigureOut">
               <a:rPr lang="en-GB" smtClean="0"/>
-              <a:t>30/04/2026</a:t>
+              <a:t>04/05/2026</a:t>
             </a:fld>
             <a:endParaRPr lang="en-GB"/>
           </a:p>
@@ -6582,7 +6584,7 @@
           <a:p>
             <a:fld id="{842CECD3-3569-4D6E-AA1B-67789CA6B4B3}" type="datetimeFigureOut">
               <a:rPr lang="en-GB" smtClean="0"/>
-              <a:t>30/04/2026</a:t>
+              <a:t>04/05/2026</a:t>
             </a:fld>
             <a:endParaRPr lang="en-GB"/>
           </a:p>
@@ -6832,7 +6834,7 @@
           <a:p>
             <a:fld id="{842CECD3-3569-4D6E-AA1B-67789CA6B4B3}" type="datetimeFigureOut">
               <a:rPr lang="en-GB" smtClean="0"/>
-              <a:t>30/04/2026</a:t>
+              <a:t>04/05/2026</a:t>
             </a:fld>
             <a:endParaRPr lang="en-GB"/>
           </a:p>
@@ -7140,7 +7142,7 @@
           <a:p>
             <a:fld id="{842CECD3-3569-4D6E-AA1B-67789CA6B4B3}" type="datetimeFigureOut">
               <a:rPr lang="en-GB" smtClean="0"/>
-              <a:t>30/04/2026</a:t>
+              <a:t>04/05/2026</a:t>
             </a:fld>
             <a:endParaRPr lang="en-GB"/>
           </a:p>
@@ -7458,7 +7460,7 @@
           <a:p>
             <a:fld id="{842CECD3-3569-4D6E-AA1B-67789CA6B4B3}" type="datetimeFigureOut">
               <a:rPr lang="en-GB" smtClean="0"/>
-              <a:t>30/04/2026</a:t>
+              <a:t>04/05/2026</a:t>
             </a:fld>
             <a:endParaRPr lang="en-GB"/>
           </a:p>
@@ -7760,7 +7762,7 @@
           <a:p>
             <a:fld id="{842CECD3-3569-4D6E-AA1B-67789CA6B4B3}" type="datetimeFigureOut">
               <a:rPr lang="en-GB" smtClean="0"/>
-              <a:t>30/04/2026</a:t>
+              <a:t>04/05/2026</a:t>
             </a:fld>
             <a:endParaRPr lang="en-GB"/>
           </a:p>
@@ -8127,7 +8129,7 @@
           <a:p>
             <a:fld id="{842CECD3-3569-4D6E-AA1B-67789CA6B4B3}" type="datetimeFigureOut">
               <a:rPr lang="en-GB" smtClean="0"/>
-              <a:t>30/04/2026</a:t>
+              <a:t>04/05/2026</a:t>
             </a:fld>
             <a:endParaRPr lang="en-GB"/>
           </a:p>
@@ -8301,7 +8303,7 @@
           <a:p>
             <a:fld id="{842CECD3-3569-4D6E-AA1B-67789CA6B4B3}" type="datetimeFigureOut">
               <a:rPr lang="en-GB" smtClean="0"/>
-              <a:t>30/04/2026</a:t>
+              <a:t>04/05/2026</a:t>
             </a:fld>
             <a:endParaRPr lang="en-GB"/>
           </a:p>
@@ -8481,7 +8483,7 @@
           <a:p>
             <a:fld id="{842CECD3-3569-4D6E-AA1B-67789CA6B4B3}" type="datetimeFigureOut">
               <a:rPr lang="en-GB" smtClean="0"/>
-              <a:t>30/04/2026</a:t>
+              <a:t>04/05/2026</a:t>
             </a:fld>
             <a:endParaRPr lang="en-GB"/>
           </a:p>
@@ -8651,7 +8653,7 @@
           <a:p>
             <a:fld id="{842CECD3-3569-4D6E-AA1B-67789CA6B4B3}" type="datetimeFigureOut">
               <a:rPr lang="en-GB" smtClean="0"/>
-              <a:t>30/04/2026</a:t>
+              <a:t>04/05/2026</a:t>
             </a:fld>
             <a:endParaRPr lang="en-GB"/>
           </a:p>
@@ -8901,7 +8903,7 @@
           <a:p>
             <a:fld id="{842CECD3-3569-4D6E-AA1B-67789CA6B4B3}" type="datetimeFigureOut">
               <a:rPr lang="en-GB" smtClean="0"/>
-              <a:t>30/04/2026</a:t>
+              <a:t>04/05/2026</a:t>
             </a:fld>
             <a:endParaRPr lang="en-GB"/>
           </a:p>
@@ -9137,7 +9139,7 @@
           <a:p>
             <a:fld id="{842CECD3-3569-4D6E-AA1B-67789CA6B4B3}" type="datetimeFigureOut">
               <a:rPr lang="en-GB" smtClean="0"/>
-              <a:t>30/04/2026</a:t>
+              <a:t>04/05/2026</a:t>
             </a:fld>
             <a:endParaRPr lang="en-GB"/>
           </a:p>
@@ -9519,7 +9521,7 @@
           <a:p>
             <a:fld id="{842CECD3-3569-4D6E-AA1B-67789CA6B4B3}" type="datetimeFigureOut">
               <a:rPr lang="en-GB" smtClean="0"/>
-              <a:t>30/04/2026</a:t>
+              <a:t>04/05/2026</a:t>
             </a:fld>
             <a:endParaRPr lang="en-GB"/>
           </a:p>
@@ -9637,7 +9639,7 @@
           <a:p>
             <a:fld id="{842CECD3-3569-4D6E-AA1B-67789CA6B4B3}" type="datetimeFigureOut">
               <a:rPr lang="en-GB" smtClean="0"/>
-              <a:t>30/04/2026</a:t>
+              <a:t>04/05/2026</a:t>
             </a:fld>
             <a:endParaRPr lang="en-GB"/>
           </a:p>
@@ -9732,7 +9734,7 @@
           <a:p>
             <a:fld id="{842CECD3-3569-4D6E-AA1B-67789CA6B4B3}" type="datetimeFigureOut">
               <a:rPr lang="en-GB" smtClean="0"/>
-              <a:t>30/04/2026</a:t>
+              <a:t>04/05/2026</a:t>
             </a:fld>
             <a:endParaRPr lang="en-GB"/>
           </a:p>
@@ -9987,7 +9989,7 @@
           <a:p>
             <a:fld id="{842CECD3-3569-4D6E-AA1B-67789CA6B4B3}" type="datetimeFigureOut">
               <a:rPr lang="en-GB" smtClean="0"/>
-              <a:t>30/04/2026</a:t>
+              <a:t>04/05/2026</a:t>
             </a:fld>
             <a:endParaRPr lang="en-GB"/>
           </a:p>
@@ -10270,7 +10272,7 @@
           <a:p>
             <a:fld id="{842CECD3-3569-4D6E-AA1B-67789CA6B4B3}" type="datetimeFigureOut">
               <a:rPr lang="en-GB" smtClean="0"/>
-              <a:t>30/04/2026</a:t>
+              <a:t>04/05/2026</a:t>
             </a:fld>
             <a:endParaRPr lang="en-GB"/>
           </a:p>
@@ -10676,7 +10678,7 @@
           <a:p>
             <a:fld id="{842CECD3-3569-4D6E-AA1B-67789CA6B4B3}" type="datetimeFigureOut">
               <a:rPr lang="en-GB" smtClean="0"/>
-              <a:t>30/04/2026</a:t>
+              <a:t>04/05/2026</a:t>
             </a:fld>
             <a:endParaRPr lang="en-GB"/>
           </a:p>
@@ -11741,6 +11743,29 @@
               <a:t> per poter esser richiamato ogni volta fosse necessario provare una combinazione.</a:t>
             </a:r>
           </a:p>
+          <a:p>
+            <a:r>
+              <a:rPr lang="it-IT" dirty="0">
+                <a:solidFill>
+                  <a:schemeClr val="tx1"/>
+                </a:solidFill>
+              </a:rPr>
+              <a:t>Si è </a:t>
+            </a:r>
+            <a:r>
+              <a:rPr lang="it-IT">
+                <a:solidFill>
+                  <a:schemeClr val="tx1"/>
+                </a:solidFill>
+              </a:rPr>
+              <a:t>fatto affidamento su una GPU RTX 2000 Ada (16 GB VRAM)</a:t>
+            </a:r>
+            <a:endParaRPr lang="it-IT" dirty="0">
+              <a:solidFill>
+                <a:schemeClr val="tx1"/>
+              </a:solidFill>
+            </a:endParaRPr>
+          </a:p>
         </p:txBody>
       </p:sp>
     </p:spTree>
@@ -12020,7 +12045,166 @@
           <a:bodyPr/>
           <a:lstStyle/>
           <a:p>
-            <a:endParaRPr lang="en-GB"/>
+            <a:r>
+              <a:rPr lang="it-IT" dirty="0" err="1">
+                <a:solidFill>
+                  <a:schemeClr val="tx1"/>
+                </a:solidFill>
+              </a:rPr>
+              <a:t>Gbce_t</a:t>
+            </a:r>
+            <a:r>
+              <a:rPr lang="it-IT" dirty="0">
+                <a:solidFill>
+                  <a:schemeClr val="tx1"/>
+                </a:solidFill>
+              </a:rPr>
+              <a:t>: [0.0, 0.5, 0.75, 1.0]*</a:t>
+            </a:r>
+          </a:p>
+          <a:p>
+            <a:r>
+              <a:rPr lang="it-IT" dirty="0" err="1">
+                <a:solidFill>
+                  <a:schemeClr val="tx1"/>
+                </a:solidFill>
+              </a:rPr>
+              <a:t>Num_blocks</a:t>
+            </a:r>
+            <a:r>
+              <a:rPr lang="it-IT" dirty="0">
+                <a:solidFill>
+                  <a:schemeClr val="tx1"/>
+                </a:solidFill>
+              </a:rPr>
+              <a:t>: [1, 3]</a:t>
+            </a:r>
+          </a:p>
+          <a:p>
+            <a:r>
+              <a:rPr lang="it-IT" dirty="0" err="1">
+                <a:solidFill>
+                  <a:schemeClr val="tx1"/>
+                </a:solidFill>
+              </a:rPr>
+              <a:t>Embedding_dim</a:t>
+            </a:r>
+            <a:r>
+              <a:rPr lang="it-IT" dirty="0">
+                <a:solidFill>
+                  <a:schemeClr val="tx1"/>
+                </a:solidFill>
+              </a:rPr>
+              <a:t>: [128, 256]*</a:t>
+            </a:r>
+          </a:p>
+          <a:p>
+            <a:r>
+              <a:rPr lang="it-IT" dirty="0" err="1">
+                <a:solidFill>
+                  <a:schemeClr val="tx1"/>
+                </a:solidFill>
+              </a:rPr>
+              <a:t>Num_heads</a:t>
+            </a:r>
+            <a:r>
+              <a:rPr lang="it-IT" dirty="0">
+                <a:solidFill>
+                  <a:schemeClr val="tx1"/>
+                </a:solidFill>
+              </a:rPr>
+              <a:t>: [2, 4]*</a:t>
+            </a:r>
+          </a:p>
+          <a:p>
+            <a:r>
+              <a:rPr lang="it-IT" dirty="0" err="1">
+                <a:solidFill>
+                  <a:schemeClr val="tx1"/>
+                </a:solidFill>
+              </a:rPr>
+              <a:t>Dropout_rate</a:t>
+            </a:r>
+            <a:r>
+              <a:rPr lang="it-IT" dirty="0">
+                <a:solidFill>
+                  <a:schemeClr val="tx1"/>
+                </a:solidFill>
+              </a:rPr>
+              <a:t>: [0.1, 0.5]</a:t>
+            </a:r>
+          </a:p>
+          <a:p>
+            <a:r>
+              <a:rPr lang="it-IT" dirty="0" err="1">
+                <a:solidFill>
+                  <a:schemeClr val="tx1"/>
+                </a:solidFill>
+              </a:rPr>
+              <a:t>Train_batch_size</a:t>
+            </a:r>
+            <a:r>
+              <a:rPr lang="it-IT" dirty="0">
+                <a:solidFill>
+                  <a:schemeClr val="tx1"/>
+                </a:solidFill>
+              </a:rPr>
+              <a:t>: [64, 128]*</a:t>
+            </a:r>
+          </a:p>
+          <a:p>
+            <a:r>
+              <a:rPr lang="it-IT" dirty="0" err="1">
+                <a:solidFill>
+                  <a:schemeClr val="tx1"/>
+                </a:solidFill>
+              </a:rPr>
+              <a:t>Sequence_length</a:t>
+            </a:r>
+            <a:r>
+              <a:rPr lang="it-IT" dirty="0">
+                <a:solidFill>
+                  <a:schemeClr val="tx1"/>
+                </a:solidFill>
+              </a:rPr>
+              <a:t>: [50, 100, 200]*</a:t>
+            </a:r>
+          </a:p>
+        </p:txBody>
+      </p:sp>
+      <p:sp>
+        <p:nvSpPr>
+          <p:cNvPr id="4" name="TextBox 3">
+            <a:extLst>
+              <a:ext uri="{FF2B5EF4-FFF2-40B4-BE49-F238E27FC236}">
+                <a16:creationId xmlns:a16="http://schemas.microsoft.com/office/drawing/2014/main" id="{A830D6F5-3392-1923-6944-A4BA6AB756FB}"/>
+              </a:ext>
+            </a:extLst>
+          </p:cNvPr>
+          <p:cNvSpPr txBox="1"/>
+          <p:nvPr/>
+        </p:nvSpPr>
+        <p:spPr>
+          <a:xfrm>
+            <a:off x="186812" y="6361470"/>
+            <a:ext cx="2172390" cy="369332"/>
+          </a:xfrm>
+          <a:prstGeom prst="rect">
+            <a:avLst/>
+          </a:prstGeom>
+          <a:noFill/>
+        </p:spPr>
+        <p:txBody>
+          <a:bodyPr wrap="none" rtlCol="0">
+            <a:spAutoFit/>
+          </a:bodyPr>
+          <a:lstStyle/>
+          <a:p>
+            <a:r>
+              <a:rPr lang="it-IT" dirty="0"/>
+              <a:t>*range categorici</a:t>
+            </a:r>
+            <a:endParaRPr lang="en-GB" dirty="0"/>
           </a:p>
         </p:txBody>
       </p:sp>
@@ -12028,6 +12212,398 @@
     <p:extLst>
       <p:ext uri="{BB962C8B-B14F-4D97-AF65-F5344CB8AC3E}">
         <p14:creationId xmlns:p14="http://schemas.microsoft.com/office/powerpoint/2010/main" val="1824266746"/>
+      </p:ext>
+    </p:extLst>
+  </p:cSld>
+  <p:clrMapOvr>
+    <a:masterClrMapping/>
+  </p:clrMapOvr>
+</p:sld>
+</file>
+
+<file path=ppt/slides/slide14.xml><?xml version="1.0" encoding="utf-8"?>
+<p:sld xmlns:a="http://schemas.openxmlformats.org/drawingml/2006/main" xmlns:r="http://schemas.openxmlformats.org/officeDocument/2006/relationships" xmlns:p="http://schemas.openxmlformats.org/presentationml/2006/main">
+  <p:cSld>
+    <p:spTree>
+      <p:nvGrpSpPr>
+        <p:cNvPr id="1" name=""/>
+        <p:cNvGrpSpPr/>
+        <p:nvPr/>
+      </p:nvGrpSpPr>
+      <p:grpSpPr>
+        <a:xfrm>
+          <a:off x="0" y="0"/>
+          <a:ext cx="0" cy="0"/>
+          <a:chOff x="0" y="0"/>
+          <a:chExt cx="0" cy="0"/>
+        </a:xfrm>
+      </p:grpSpPr>
+      <p:sp>
+        <p:nvSpPr>
+          <p:cNvPr id="2" name="Title 1">
+            <a:extLst>
+              <a:ext uri="{FF2B5EF4-FFF2-40B4-BE49-F238E27FC236}">
+                <a16:creationId xmlns:a16="http://schemas.microsoft.com/office/drawing/2014/main" id="{B95B4631-4F9F-3FD6-4B56-D870AD8F3EAE}"/>
+              </a:ext>
+            </a:extLst>
+          </p:cNvPr>
+          <p:cNvSpPr>
+            <a:spLocks noGrp="1"/>
+          </p:cNvSpPr>
+          <p:nvPr>
+            <p:ph type="title"/>
+          </p:nvPr>
+        </p:nvSpPr>
+        <p:spPr/>
+        <p:txBody>
+          <a:bodyPr/>
+          <a:lstStyle/>
+          <a:p>
+            <a:r>
+              <a:rPr lang="it-IT" dirty="0"/>
+              <a:t>MIGLIOR CONFIGURAZIONE</a:t>
+            </a:r>
+            <a:endParaRPr lang="en-GB" dirty="0"/>
+          </a:p>
+        </p:txBody>
+      </p:sp>
+      <p:sp>
+        <p:nvSpPr>
+          <p:cNvPr id="3" name="Content Placeholder 2">
+            <a:extLst>
+              <a:ext uri="{FF2B5EF4-FFF2-40B4-BE49-F238E27FC236}">
+                <a16:creationId xmlns:a16="http://schemas.microsoft.com/office/drawing/2014/main" id="{C6763A6F-58BE-4F86-3846-CEA3F0DF2B91}"/>
+              </a:ext>
+            </a:extLst>
+          </p:cNvPr>
+          <p:cNvSpPr>
+            <a:spLocks noGrp="1"/>
+          </p:cNvSpPr>
+          <p:nvPr>
+            <p:ph idx="1"/>
+          </p:nvPr>
+        </p:nvSpPr>
+        <p:spPr/>
+        <p:txBody>
+          <a:bodyPr>
+            <a:normAutofit fontScale="85000" lnSpcReduction="10000"/>
+          </a:bodyPr>
+          <a:lstStyle/>
+          <a:p>
+            <a:pPr marL="0" indent="0">
+              <a:buNone/>
+            </a:pPr>
+            <a:r>
+              <a:rPr lang="it-IT" dirty="0">
+                <a:solidFill>
+                  <a:schemeClr val="tx1"/>
+                </a:solidFill>
+              </a:rPr>
+              <a:t>La miglior configurazione dopo 20 trials, ha presentato i seguenti parametri (messi a confronto con quelli usati dagli autori del modello): </a:t>
+            </a:r>
+          </a:p>
+          <a:p>
+            <a:r>
+              <a:rPr lang="it-IT" dirty="0" err="1">
+                <a:solidFill>
+                  <a:schemeClr val="tx1"/>
+                </a:solidFill>
+              </a:rPr>
+              <a:t>gbce_t</a:t>
+            </a:r>
+            <a:r>
+              <a:rPr lang="it-IT" dirty="0">
+                <a:solidFill>
+                  <a:schemeClr val="tx1"/>
+                </a:solidFill>
+              </a:rPr>
+              <a:t>: 0.5 (0.75)</a:t>
+            </a:r>
+          </a:p>
+          <a:p>
+            <a:r>
+              <a:rPr lang="it-IT" dirty="0" err="1">
+                <a:solidFill>
+                  <a:schemeClr val="tx1"/>
+                </a:solidFill>
+              </a:rPr>
+              <a:t>num_blocks</a:t>
+            </a:r>
+            <a:r>
+              <a:rPr lang="it-IT" dirty="0">
+                <a:solidFill>
+                  <a:schemeClr val="tx1"/>
+                </a:solidFill>
+              </a:rPr>
+              <a:t>: 1 (2)</a:t>
+            </a:r>
+          </a:p>
+          <a:p>
+            <a:r>
+              <a:rPr lang="it-IT" dirty="0" err="1">
+                <a:solidFill>
+                  <a:schemeClr val="tx1"/>
+                </a:solidFill>
+              </a:rPr>
+              <a:t>embedding_dim</a:t>
+            </a:r>
+            <a:r>
+              <a:rPr lang="it-IT" dirty="0">
+                <a:solidFill>
+                  <a:schemeClr val="tx1"/>
+                </a:solidFill>
+              </a:rPr>
+              <a:t>: 256 (128)</a:t>
+            </a:r>
+          </a:p>
+          <a:p>
+            <a:r>
+              <a:rPr lang="it-IT" dirty="0" err="1">
+                <a:solidFill>
+                  <a:schemeClr val="tx1"/>
+                </a:solidFill>
+              </a:rPr>
+              <a:t>num_heads</a:t>
+            </a:r>
+            <a:r>
+              <a:rPr lang="it-IT" dirty="0">
+                <a:solidFill>
+                  <a:schemeClr val="tx1"/>
+                </a:solidFill>
+              </a:rPr>
+              <a:t>: 4 (1)</a:t>
+            </a:r>
+          </a:p>
+          <a:p>
+            <a:r>
+              <a:rPr lang="it-IT" dirty="0" err="1">
+                <a:solidFill>
+                  <a:schemeClr val="tx1"/>
+                </a:solidFill>
+              </a:rPr>
+              <a:t>dropout_rate</a:t>
+            </a:r>
+            <a:r>
+              <a:rPr lang="it-IT" dirty="0">
+                <a:solidFill>
+                  <a:schemeClr val="tx1"/>
+                </a:solidFill>
+              </a:rPr>
+              <a:t>: 0.16519583830077267 (0.5)</a:t>
+            </a:r>
+          </a:p>
+          <a:p>
+            <a:r>
+              <a:rPr lang="it-IT" dirty="0" err="1">
+                <a:solidFill>
+                  <a:schemeClr val="tx1"/>
+                </a:solidFill>
+              </a:rPr>
+              <a:t>train_batch_size</a:t>
+            </a:r>
+            <a:r>
+              <a:rPr lang="it-IT" dirty="0">
+                <a:solidFill>
+                  <a:schemeClr val="tx1"/>
+                </a:solidFill>
+              </a:rPr>
+              <a:t>: 64 (128)</a:t>
+            </a:r>
+          </a:p>
+          <a:p>
+            <a:r>
+              <a:rPr lang="it-IT" dirty="0" err="1">
+                <a:solidFill>
+                  <a:schemeClr val="tx1"/>
+                </a:solidFill>
+              </a:rPr>
+              <a:t>sequence_length</a:t>
+            </a:r>
+            <a:r>
+              <a:rPr lang="it-IT" dirty="0">
+                <a:solidFill>
+                  <a:schemeClr val="tx1"/>
+                </a:solidFill>
+              </a:rPr>
+              <a:t>: 200 (200)</a:t>
+            </a:r>
+          </a:p>
+          <a:p>
+            <a:pPr marL="0" indent="0">
+              <a:buNone/>
+            </a:pPr>
+            <a:r>
+              <a:rPr lang="it-IT" dirty="0">
+                <a:solidFill>
+                  <a:schemeClr val="tx1"/>
+                </a:solidFill>
+              </a:rPr>
+              <a:t>Con NDGC@10 pari a 0.1349321142424068 (0.197) dopo 3910 (47520) step.</a:t>
+            </a:r>
+            <a:endParaRPr lang="en-GB" dirty="0">
+              <a:solidFill>
+                <a:schemeClr val="tx1"/>
+              </a:solidFill>
+            </a:endParaRPr>
+          </a:p>
+        </p:txBody>
+      </p:sp>
+    </p:spTree>
+    <p:extLst>
+      <p:ext uri="{BB962C8B-B14F-4D97-AF65-F5344CB8AC3E}">
+        <p14:creationId xmlns:p14="http://schemas.microsoft.com/office/powerpoint/2010/main" val="699051150"/>
+      </p:ext>
+    </p:extLst>
+  </p:cSld>
+  <p:clrMapOvr>
+    <a:masterClrMapping/>
+  </p:clrMapOvr>
+</p:sld>
+</file>
+
+<file path=ppt/slides/slide15.xml><?xml version="1.0" encoding="utf-8"?>
+<p:sld xmlns:a="http://schemas.openxmlformats.org/drawingml/2006/main" xmlns:r="http://schemas.openxmlformats.org/officeDocument/2006/relationships" xmlns:p="http://schemas.openxmlformats.org/presentationml/2006/main">
+  <p:cSld>
+    <p:spTree>
+      <p:nvGrpSpPr>
+        <p:cNvPr id="1" name=""/>
+        <p:cNvGrpSpPr/>
+        <p:nvPr/>
+      </p:nvGrpSpPr>
+      <p:grpSpPr>
+        <a:xfrm>
+          <a:off x="0" y="0"/>
+          <a:ext cx="0" cy="0"/>
+          <a:chOff x="0" y="0"/>
+          <a:chExt cx="0" cy="0"/>
+        </a:xfrm>
+      </p:grpSpPr>
+      <p:sp>
+        <p:nvSpPr>
+          <p:cNvPr id="2" name="Title 1">
+            <a:extLst>
+              <a:ext uri="{FF2B5EF4-FFF2-40B4-BE49-F238E27FC236}">
+                <a16:creationId xmlns:a16="http://schemas.microsoft.com/office/drawing/2014/main" id="{77C8BED9-814F-5653-73A0-116D66833313}"/>
+              </a:ext>
+            </a:extLst>
+          </p:cNvPr>
+          <p:cNvSpPr>
+            <a:spLocks noGrp="1"/>
+          </p:cNvSpPr>
+          <p:nvPr>
+            <p:ph type="title"/>
+          </p:nvPr>
+        </p:nvSpPr>
+        <p:spPr/>
+        <p:txBody>
+          <a:bodyPr/>
+          <a:lstStyle/>
+          <a:p>
+            <a:r>
+              <a:rPr lang="it-IT" dirty="0" err="1"/>
+              <a:t>CONFronto</a:t>
+            </a:r>
+            <a:r>
+              <a:rPr lang="it-IT" dirty="0"/>
+              <a:t> </a:t>
+            </a:r>
+            <a:r>
+              <a:rPr lang="it-IT" dirty="0" err="1"/>
+              <a:t>evaluation</a:t>
+            </a:r>
+            <a:r>
+              <a:rPr lang="it-IT" dirty="0"/>
+              <a:t> test</a:t>
+            </a:r>
+            <a:endParaRPr lang="en-GB" dirty="0"/>
+          </a:p>
+        </p:txBody>
+      </p:sp>
+      <p:sp>
+        <p:nvSpPr>
+          <p:cNvPr id="3" name="Content Placeholder 2">
+            <a:extLst>
+              <a:ext uri="{FF2B5EF4-FFF2-40B4-BE49-F238E27FC236}">
+                <a16:creationId xmlns:a16="http://schemas.microsoft.com/office/drawing/2014/main" id="{9E2E907B-C619-80AB-4390-B2B94F2F8EE7}"/>
+              </a:ext>
+            </a:extLst>
+          </p:cNvPr>
+          <p:cNvSpPr>
+            <a:spLocks noGrp="1"/>
+          </p:cNvSpPr>
+          <p:nvPr>
+            <p:ph idx="1"/>
+          </p:nvPr>
+        </p:nvSpPr>
+        <p:spPr/>
+        <p:txBody>
+          <a:bodyPr/>
+          <a:lstStyle/>
+          <a:p>
+            <a:pPr marL="0" indent="0">
+              <a:buNone/>
+            </a:pPr>
+            <a:r>
+              <a:rPr lang="it-IT" dirty="0">
+                <a:solidFill>
+                  <a:schemeClr val="tx1"/>
+                </a:solidFill>
+              </a:rPr>
+              <a:t>Qui di seguito i risultati differenti </a:t>
+            </a:r>
+            <a:r>
+              <a:rPr lang="it-IT" dirty="0" err="1">
+                <a:solidFill>
+                  <a:schemeClr val="tx1"/>
+                </a:solidFill>
+              </a:rPr>
+              <a:t>sull’evaluation</a:t>
+            </a:r>
+            <a:r>
+              <a:rPr lang="it-IT" dirty="0">
+                <a:solidFill>
+                  <a:schemeClr val="tx1"/>
+                </a:solidFill>
+              </a:rPr>
+              <a:t> set per il miglior modello e l’originale del paper:</a:t>
+            </a:r>
+          </a:p>
+          <a:p>
+            <a:r>
+              <a:rPr lang="it-IT">
+                <a:solidFill>
+                  <a:schemeClr val="tx1"/>
+                </a:solidFill>
+              </a:rPr>
+              <a:t>Miglior modello: {R@1: 0.05099337748344371, R@10: 0.2052980132450331, nDCG@10: 0.11809304395337882}</a:t>
+            </a:r>
+            <a:endParaRPr lang="it-IT" dirty="0">
+              <a:solidFill>
+                <a:schemeClr val="tx1"/>
+              </a:solidFill>
+            </a:endParaRPr>
+          </a:p>
+          <a:p>
+            <a:r>
+              <a:rPr lang="it-IT" dirty="0">
+                <a:solidFill>
+                  <a:schemeClr val="tx1"/>
+                </a:solidFill>
+              </a:rPr>
+              <a:t>Originale: {R@1: 0.07549668874172186, nDCG@10: 0.17261420098894456, R@10: 0.30033112582781457}</a:t>
+            </a:r>
+            <a:endParaRPr lang="en-GB" dirty="0">
+              <a:solidFill>
+                <a:schemeClr val="tx1"/>
+              </a:solidFill>
+            </a:endParaRPr>
+          </a:p>
+        </p:txBody>
+      </p:sp>
+    </p:spTree>
+    <p:extLst>
+      <p:ext uri="{BB962C8B-B14F-4D97-AF65-F5344CB8AC3E}">
+        <p14:creationId xmlns:p14="http://schemas.microsoft.com/office/powerpoint/2010/main" val="238369433"/>
       </p:ext>
     </p:extLst>
   </p:cSld>

</xml_diff>

<commit_message>
Update: adding a load test logic for the endpoint
</commit_message>
<xml_diff>
--- a/Gsasrec.pptx
+++ b/Gsasrec.pptx
@@ -20,6 +20,11 @@
     <p:sldId id="268" r:id="rId14"/>
     <p:sldId id="269" r:id="rId15"/>
     <p:sldId id="270" r:id="rId16"/>
+    <p:sldId id="271" r:id="rId17"/>
+    <p:sldId id="272" r:id="rId18"/>
+    <p:sldId id="273" r:id="rId19"/>
+    <p:sldId id="274" r:id="rId20"/>
+    <p:sldId id="275" r:id="rId21"/>
   </p:sldIdLst>
   <p:sldSz cx="12192000" cy="6858000"/>
   <p:notesSz cx="6858000" cy="9144000"/>
@@ -6148,7 +6153,7 @@
           <a:p>
             <a:fld id="{842CECD3-3569-4D6E-AA1B-67789CA6B4B3}" type="datetimeFigureOut">
               <a:rPr lang="en-GB" smtClean="0"/>
-              <a:t>04/05/2026</a:t>
+              <a:t>05/05/2026</a:t>
             </a:fld>
             <a:endParaRPr lang="en-GB"/>
           </a:p>
@@ -6584,7 +6589,7 @@
           <a:p>
             <a:fld id="{842CECD3-3569-4D6E-AA1B-67789CA6B4B3}" type="datetimeFigureOut">
               <a:rPr lang="en-GB" smtClean="0"/>
-              <a:t>04/05/2026</a:t>
+              <a:t>05/05/2026</a:t>
             </a:fld>
             <a:endParaRPr lang="en-GB"/>
           </a:p>
@@ -6834,7 +6839,7 @@
           <a:p>
             <a:fld id="{842CECD3-3569-4D6E-AA1B-67789CA6B4B3}" type="datetimeFigureOut">
               <a:rPr lang="en-GB" smtClean="0"/>
-              <a:t>04/05/2026</a:t>
+              <a:t>05/05/2026</a:t>
             </a:fld>
             <a:endParaRPr lang="en-GB"/>
           </a:p>
@@ -7142,7 +7147,7 @@
           <a:p>
             <a:fld id="{842CECD3-3569-4D6E-AA1B-67789CA6B4B3}" type="datetimeFigureOut">
               <a:rPr lang="en-GB" smtClean="0"/>
-              <a:t>04/05/2026</a:t>
+              <a:t>05/05/2026</a:t>
             </a:fld>
             <a:endParaRPr lang="en-GB"/>
           </a:p>
@@ -7460,7 +7465,7 @@
           <a:p>
             <a:fld id="{842CECD3-3569-4D6E-AA1B-67789CA6B4B3}" type="datetimeFigureOut">
               <a:rPr lang="en-GB" smtClean="0"/>
-              <a:t>04/05/2026</a:t>
+              <a:t>05/05/2026</a:t>
             </a:fld>
             <a:endParaRPr lang="en-GB"/>
           </a:p>
@@ -7762,7 +7767,7 @@
           <a:p>
             <a:fld id="{842CECD3-3569-4D6E-AA1B-67789CA6B4B3}" type="datetimeFigureOut">
               <a:rPr lang="en-GB" smtClean="0"/>
-              <a:t>04/05/2026</a:t>
+              <a:t>05/05/2026</a:t>
             </a:fld>
             <a:endParaRPr lang="en-GB"/>
           </a:p>
@@ -8129,7 +8134,7 @@
           <a:p>
             <a:fld id="{842CECD3-3569-4D6E-AA1B-67789CA6B4B3}" type="datetimeFigureOut">
               <a:rPr lang="en-GB" smtClean="0"/>
-              <a:t>04/05/2026</a:t>
+              <a:t>05/05/2026</a:t>
             </a:fld>
             <a:endParaRPr lang="en-GB"/>
           </a:p>
@@ -8303,7 +8308,7 @@
           <a:p>
             <a:fld id="{842CECD3-3569-4D6E-AA1B-67789CA6B4B3}" type="datetimeFigureOut">
               <a:rPr lang="en-GB" smtClean="0"/>
-              <a:t>04/05/2026</a:t>
+              <a:t>05/05/2026</a:t>
             </a:fld>
             <a:endParaRPr lang="en-GB"/>
           </a:p>
@@ -8483,7 +8488,7 @@
           <a:p>
             <a:fld id="{842CECD3-3569-4D6E-AA1B-67789CA6B4B3}" type="datetimeFigureOut">
               <a:rPr lang="en-GB" smtClean="0"/>
-              <a:t>04/05/2026</a:t>
+              <a:t>05/05/2026</a:t>
             </a:fld>
             <a:endParaRPr lang="en-GB"/>
           </a:p>
@@ -8653,7 +8658,7 @@
           <a:p>
             <a:fld id="{842CECD3-3569-4D6E-AA1B-67789CA6B4B3}" type="datetimeFigureOut">
               <a:rPr lang="en-GB" smtClean="0"/>
-              <a:t>04/05/2026</a:t>
+              <a:t>05/05/2026</a:t>
             </a:fld>
             <a:endParaRPr lang="en-GB"/>
           </a:p>
@@ -8903,7 +8908,7 @@
           <a:p>
             <a:fld id="{842CECD3-3569-4D6E-AA1B-67789CA6B4B3}" type="datetimeFigureOut">
               <a:rPr lang="en-GB" smtClean="0"/>
-              <a:t>04/05/2026</a:t>
+              <a:t>05/05/2026</a:t>
             </a:fld>
             <a:endParaRPr lang="en-GB"/>
           </a:p>
@@ -9139,7 +9144,7 @@
           <a:p>
             <a:fld id="{842CECD3-3569-4D6E-AA1B-67789CA6B4B3}" type="datetimeFigureOut">
               <a:rPr lang="en-GB" smtClean="0"/>
-              <a:t>04/05/2026</a:t>
+              <a:t>05/05/2026</a:t>
             </a:fld>
             <a:endParaRPr lang="en-GB"/>
           </a:p>
@@ -9521,7 +9526,7 @@
           <a:p>
             <a:fld id="{842CECD3-3569-4D6E-AA1B-67789CA6B4B3}" type="datetimeFigureOut">
               <a:rPr lang="en-GB" smtClean="0"/>
-              <a:t>04/05/2026</a:t>
+              <a:t>05/05/2026</a:t>
             </a:fld>
             <a:endParaRPr lang="en-GB"/>
           </a:p>
@@ -9639,7 +9644,7 @@
           <a:p>
             <a:fld id="{842CECD3-3569-4D6E-AA1B-67789CA6B4B3}" type="datetimeFigureOut">
               <a:rPr lang="en-GB" smtClean="0"/>
-              <a:t>04/05/2026</a:t>
+              <a:t>05/05/2026</a:t>
             </a:fld>
             <a:endParaRPr lang="en-GB"/>
           </a:p>
@@ -9734,7 +9739,7 @@
           <a:p>
             <a:fld id="{842CECD3-3569-4D6E-AA1B-67789CA6B4B3}" type="datetimeFigureOut">
               <a:rPr lang="en-GB" smtClean="0"/>
-              <a:t>04/05/2026</a:t>
+              <a:t>05/05/2026</a:t>
             </a:fld>
             <a:endParaRPr lang="en-GB"/>
           </a:p>
@@ -9989,7 +9994,7 @@
           <a:p>
             <a:fld id="{842CECD3-3569-4D6E-AA1B-67789CA6B4B3}" type="datetimeFigureOut">
               <a:rPr lang="en-GB" smtClean="0"/>
-              <a:t>04/05/2026</a:t>
+              <a:t>05/05/2026</a:t>
             </a:fld>
             <a:endParaRPr lang="en-GB"/>
           </a:p>
@@ -10272,7 +10277,7 @@
           <a:p>
             <a:fld id="{842CECD3-3569-4D6E-AA1B-67789CA6B4B3}" type="datetimeFigureOut">
               <a:rPr lang="en-GB" smtClean="0"/>
-              <a:t>04/05/2026</a:t>
+              <a:t>05/05/2026</a:t>
             </a:fld>
             <a:endParaRPr lang="en-GB"/>
           </a:p>
@@ -10678,7 +10683,7 @@
           <a:p>
             <a:fld id="{842CECD3-3569-4D6E-AA1B-67789CA6B4B3}" type="datetimeFigureOut">
               <a:rPr lang="en-GB" smtClean="0"/>
-              <a:t>04/05/2026</a:t>
+              <a:t>05/05/2026</a:t>
             </a:fld>
             <a:endParaRPr lang="en-GB"/>
           </a:p>
@@ -12438,7 +12443,7 @@
                   <a:schemeClr val="tx1"/>
                 </a:solidFill>
               </a:rPr>
-              <a:t>Con NDGC@10 pari a 0.1349321142424068 (0.197) dopo 3910 (47520) step.</a:t>
+              <a:t>Con NDCG@10 pari a 0.1349321142424068 (0.197) dopo 3910 (47520) step.</a:t>
             </a:r>
             <a:endParaRPr lang="en-GB" dirty="0">
               <a:solidFill>
@@ -12570,18 +12575,13 @@
           </a:p>
           <a:p>
             <a:r>
-              <a:rPr lang="it-IT">
+              <a:rPr lang="it-IT" dirty="0">
                 <a:solidFill>
                   <a:schemeClr val="tx1"/>
                 </a:solidFill>
               </a:rPr>
               <a:t>Miglior modello: {R@1: 0.05099337748344371, R@10: 0.2052980132450331, nDCG@10: 0.11809304395337882}</a:t>
             </a:r>
-            <a:endParaRPr lang="it-IT" dirty="0">
-              <a:solidFill>
-                <a:schemeClr val="tx1"/>
-              </a:solidFill>
-            </a:endParaRPr>
           </a:p>
           <a:p>
             <a:r>
@@ -12604,6 +12604,604 @@
     <p:extLst>
       <p:ext uri="{BB962C8B-B14F-4D97-AF65-F5344CB8AC3E}">
         <p14:creationId xmlns:p14="http://schemas.microsoft.com/office/powerpoint/2010/main" val="238369433"/>
+      </p:ext>
+    </p:extLst>
+  </p:cSld>
+  <p:clrMapOvr>
+    <a:masterClrMapping/>
+  </p:clrMapOvr>
+</p:sld>
+</file>
+
+<file path=ppt/slides/slide16.xml><?xml version="1.0" encoding="utf-8"?>
+<p:sld xmlns:a="http://schemas.openxmlformats.org/drawingml/2006/main" xmlns:r="http://schemas.openxmlformats.org/officeDocument/2006/relationships" xmlns:p="http://schemas.openxmlformats.org/presentationml/2006/main">
+  <p:cSld>
+    <p:spTree>
+      <p:nvGrpSpPr>
+        <p:cNvPr id="1" name=""/>
+        <p:cNvGrpSpPr/>
+        <p:nvPr/>
+      </p:nvGrpSpPr>
+      <p:grpSpPr>
+        <a:xfrm>
+          <a:off x="0" y="0"/>
+          <a:ext cx="0" cy="0"/>
+          <a:chOff x="0" y="0"/>
+          <a:chExt cx="0" cy="0"/>
+        </a:xfrm>
+      </p:grpSpPr>
+      <p:sp>
+        <p:nvSpPr>
+          <p:cNvPr id="2" name="Title 1">
+            <a:extLst>
+              <a:ext uri="{FF2B5EF4-FFF2-40B4-BE49-F238E27FC236}">
+                <a16:creationId xmlns:a16="http://schemas.microsoft.com/office/drawing/2014/main" id="{864BB684-58E5-DF5B-0C8D-284EEEA5AA31}"/>
+              </a:ext>
+            </a:extLst>
+          </p:cNvPr>
+          <p:cNvSpPr>
+            <a:spLocks noGrp="1"/>
+          </p:cNvSpPr>
+          <p:nvPr>
+            <p:ph type="title"/>
+          </p:nvPr>
+        </p:nvSpPr>
+        <p:spPr/>
+        <p:txBody>
+          <a:bodyPr/>
+          <a:lstStyle/>
+          <a:p>
+            <a:r>
+              <a:rPr lang="it-IT" dirty="0"/>
+              <a:t>DIFFERENZE DOPO IL TRAINING</a:t>
+            </a:r>
+            <a:endParaRPr lang="en-GB" dirty="0"/>
+          </a:p>
+        </p:txBody>
+      </p:sp>
+      <p:sp>
+        <p:nvSpPr>
+          <p:cNvPr id="3" name="Content Placeholder 2">
+            <a:extLst>
+              <a:ext uri="{FF2B5EF4-FFF2-40B4-BE49-F238E27FC236}">
+                <a16:creationId xmlns:a16="http://schemas.microsoft.com/office/drawing/2014/main" id="{FB2C392E-B43F-50FE-F1BE-1537598A1C3E}"/>
+              </a:ext>
+            </a:extLst>
+          </p:cNvPr>
+          <p:cNvSpPr>
+            <a:spLocks noGrp="1"/>
+          </p:cNvSpPr>
+          <p:nvPr>
+            <p:ph idx="1"/>
+          </p:nvPr>
+        </p:nvSpPr>
+        <p:spPr/>
+        <p:txBody>
+          <a:bodyPr/>
+          <a:lstStyle/>
+          <a:p>
+            <a:pPr marL="0" indent="0">
+              <a:buNone/>
+            </a:pPr>
+            <a:r>
+              <a:rPr lang="it-IT" dirty="0">
+                <a:solidFill>
+                  <a:schemeClr val="tx1"/>
+                </a:solidFill>
+              </a:rPr>
+              <a:t>Per poter fare una valutazione migliore si è eseguito il training con gli </a:t>
+            </a:r>
+            <a:r>
+              <a:rPr lang="it-IT" dirty="0" err="1">
+                <a:solidFill>
+                  <a:schemeClr val="tx1"/>
+                </a:solidFill>
+              </a:rPr>
+              <a:t>iperparametri</a:t>
+            </a:r>
+            <a:r>
+              <a:rPr lang="it-IT" dirty="0">
+                <a:solidFill>
+                  <a:schemeClr val="tx1"/>
+                </a:solidFill>
+              </a:rPr>
+              <a:t> forniti dagli autori del modello originale e quelli trovati con l’</a:t>
+            </a:r>
+            <a:r>
+              <a:rPr lang="it-IT" dirty="0" err="1">
+                <a:solidFill>
+                  <a:schemeClr val="tx1"/>
+                </a:solidFill>
+              </a:rPr>
+              <a:t>optimization</a:t>
+            </a:r>
+            <a:r>
+              <a:rPr lang="it-IT" dirty="0">
+                <a:solidFill>
+                  <a:schemeClr val="tx1"/>
+                </a:solidFill>
+              </a:rPr>
+              <a:t>, portando il numero massimo di epoche a 10000 e di epoche senza miglioramenti a 200, ottenendo rispettivamente:</a:t>
+            </a:r>
+          </a:p>
+          <a:p>
+            <a:r>
+              <a:rPr lang="en-GB" dirty="0">
+                <a:solidFill>
+                  <a:schemeClr val="tx1"/>
+                </a:solidFill>
+              </a:rPr>
+              <a:t>NDCG@10: 0.18758218569025115 e 0.1801849853504413</a:t>
+            </a:r>
+          </a:p>
+          <a:p>
+            <a:r>
+              <a:rPr lang="en-GB" dirty="0" err="1">
+                <a:solidFill>
+                  <a:schemeClr val="tx1"/>
+                </a:solidFill>
+              </a:rPr>
+              <a:t>Numero</a:t>
+            </a:r>
+            <a:r>
+              <a:rPr lang="en-GB" dirty="0">
+                <a:solidFill>
+                  <a:schemeClr val="tx1"/>
+                </a:solidFill>
+              </a:rPr>
+              <a:t> di step: 57984 e 24225</a:t>
+            </a:r>
+          </a:p>
+        </p:txBody>
+      </p:sp>
+    </p:spTree>
+    <p:extLst>
+      <p:ext uri="{BB962C8B-B14F-4D97-AF65-F5344CB8AC3E}">
+        <p14:creationId xmlns:p14="http://schemas.microsoft.com/office/powerpoint/2010/main" val="2289592401"/>
+      </p:ext>
+    </p:extLst>
+  </p:cSld>
+  <p:clrMapOvr>
+    <a:masterClrMapping/>
+  </p:clrMapOvr>
+</p:sld>
+</file>
+
+<file path=ppt/slides/slide17.xml><?xml version="1.0" encoding="utf-8"?>
+<p:sld xmlns:a="http://schemas.openxmlformats.org/drawingml/2006/main" xmlns:r="http://schemas.openxmlformats.org/officeDocument/2006/relationships" xmlns:p="http://schemas.openxmlformats.org/presentationml/2006/main">
+  <p:cSld>
+    <p:spTree>
+      <p:nvGrpSpPr>
+        <p:cNvPr id="1" name=""/>
+        <p:cNvGrpSpPr/>
+        <p:nvPr/>
+      </p:nvGrpSpPr>
+      <p:grpSpPr>
+        <a:xfrm>
+          <a:off x="0" y="0"/>
+          <a:ext cx="0" cy="0"/>
+          <a:chOff x="0" y="0"/>
+          <a:chExt cx="0" cy="0"/>
+        </a:xfrm>
+      </p:grpSpPr>
+      <p:sp>
+        <p:nvSpPr>
+          <p:cNvPr id="2" name="Title 1">
+            <a:extLst>
+              <a:ext uri="{FF2B5EF4-FFF2-40B4-BE49-F238E27FC236}">
+                <a16:creationId xmlns:a16="http://schemas.microsoft.com/office/drawing/2014/main" id="{C9F74094-A1ED-5C9A-8BBB-897F5AD1014A}"/>
+              </a:ext>
+            </a:extLst>
+          </p:cNvPr>
+          <p:cNvSpPr>
+            <a:spLocks noGrp="1"/>
+          </p:cNvSpPr>
+          <p:nvPr>
+            <p:ph type="title"/>
+          </p:nvPr>
+        </p:nvSpPr>
+        <p:spPr/>
+        <p:txBody>
+          <a:bodyPr/>
+          <a:lstStyle/>
+          <a:p>
+            <a:r>
+              <a:rPr lang="it-IT" dirty="0"/>
+              <a:t>CONFRONTO EVALUATION TEST</a:t>
+            </a:r>
+            <a:endParaRPr lang="en-GB" dirty="0"/>
+          </a:p>
+        </p:txBody>
+      </p:sp>
+      <p:sp>
+        <p:nvSpPr>
+          <p:cNvPr id="3" name="Content Placeholder 2">
+            <a:extLst>
+              <a:ext uri="{FF2B5EF4-FFF2-40B4-BE49-F238E27FC236}">
+                <a16:creationId xmlns:a16="http://schemas.microsoft.com/office/drawing/2014/main" id="{FC389E17-40AA-D96A-C0CB-D311F8B4DE54}"/>
+              </a:ext>
+            </a:extLst>
+          </p:cNvPr>
+          <p:cNvSpPr>
+            <a:spLocks noGrp="1"/>
+          </p:cNvSpPr>
+          <p:nvPr>
+            <p:ph idx="1"/>
+          </p:nvPr>
+        </p:nvSpPr>
+        <p:spPr/>
+        <p:txBody>
+          <a:bodyPr/>
+          <a:lstStyle/>
+          <a:p>
+            <a:pPr marL="0" indent="0">
+              <a:buNone/>
+            </a:pPr>
+            <a:r>
+              <a:rPr lang="it-IT" dirty="0">
+                <a:solidFill>
+                  <a:schemeClr val="tx1"/>
+                </a:solidFill>
+              </a:rPr>
+              <a:t>Qui di seguito i risultati differenti </a:t>
+            </a:r>
+            <a:r>
+              <a:rPr lang="it-IT" dirty="0" err="1">
+                <a:solidFill>
+                  <a:schemeClr val="tx1"/>
+                </a:solidFill>
+              </a:rPr>
+              <a:t>sull’evaluation</a:t>
+            </a:r>
+            <a:r>
+              <a:rPr lang="it-IT" dirty="0">
+                <a:solidFill>
+                  <a:schemeClr val="tx1"/>
+                </a:solidFill>
+              </a:rPr>
+              <a:t> set per il modello originale del paper e il migliore ottenuto con l’</a:t>
+            </a:r>
+            <a:r>
+              <a:rPr lang="it-IT" dirty="0" err="1">
+                <a:solidFill>
+                  <a:schemeClr val="tx1"/>
+                </a:solidFill>
+              </a:rPr>
+              <a:t>optimization</a:t>
+            </a:r>
+            <a:r>
+              <a:rPr lang="it-IT" dirty="0">
+                <a:solidFill>
+                  <a:schemeClr val="tx1"/>
+                </a:solidFill>
+              </a:rPr>
+              <a:t>:</a:t>
+            </a:r>
+            <a:endParaRPr lang="en-GB" dirty="0">
+              <a:solidFill>
+                <a:schemeClr val="tx1"/>
+              </a:solidFill>
+            </a:endParaRPr>
+          </a:p>
+          <a:p>
+            <a:r>
+              <a:rPr lang="it-IT" dirty="0">
+                <a:solidFill>
+                  <a:schemeClr val="tx1"/>
+                </a:solidFill>
+              </a:rPr>
+              <a:t>{nDCG@10: 0.1722703304771199, R@1: 0.07980132450331126, R@10: 0.2950331125827815}</a:t>
+            </a:r>
+          </a:p>
+          <a:p>
+            <a:r>
+              <a:rPr lang="it-IT" dirty="0">
+                <a:solidFill>
+                  <a:schemeClr val="tx1"/>
+                </a:solidFill>
+              </a:rPr>
+              <a:t>{R@1: 0.07102649006622516, R@10: 0.2766556291390728, nDCG@10: 0.16060628260624635}</a:t>
+            </a:r>
+          </a:p>
+        </p:txBody>
+      </p:sp>
+    </p:spTree>
+    <p:extLst>
+      <p:ext uri="{BB962C8B-B14F-4D97-AF65-F5344CB8AC3E}">
+        <p14:creationId xmlns:p14="http://schemas.microsoft.com/office/powerpoint/2010/main" val="361879204"/>
+      </p:ext>
+    </p:extLst>
+  </p:cSld>
+  <p:clrMapOvr>
+    <a:masterClrMapping/>
+  </p:clrMapOvr>
+</p:sld>
+</file>
+
+<file path=ppt/slides/slide18.xml><?xml version="1.0" encoding="utf-8"?>
+<p:sld xmlns:a="http://schemas.openxmlformats.org/drawingml/2006/main" xmlns:r="http://schemas.openxmlformats.org/officeDocument/2006/relationships" xmlns:p="http://schemas.openxmlformats.org/presentationml/2006/main">
+  <p:cSld>
+    <p:spTree>
+      <p:nvGrpSpPr>
+        <p:cNvPr id="1" name=""/>
+        <p:cNvGrpSpPr/>
+        <p:nvPr/>
+      </p:nvGrpSpPr>
+      <p:grpSpPr>
+        <a:xfrm>
+          <a:off x="0" y="0"/>
+          <a:ext cx="0" cy="0"/>
+          <a:chOff x="0" y="0"/>
+          <a:chExt cx="0" cy="0"/>
+        </a:xfrm>
+      </p:grpSpPr>
+      <p:sp>
+        <p:nvSpPr>
+          <p:cNvPr id="2" name="Title 1">
+            <a:extLst>
+              <a:ext uri="{FF2B5EF4-FFF2-40B4-BE49-F238E27FC236}">
+                <a16:creationId xmlns:a16="http://schemas.microsoft.com/office/drawing/2014/main" id="{12AFFDF8-5E3F-9581-5FF9-5EB5596A513E}"/>
+              </a:ext>
+            </a:extLst>
+          </p:cNvPr>
+          <p:cNvSpPr>
+            <a:spLocks noGrp="1"/>
+          </p:cNvSpPr>
+          <p:nvPr>
+            <p:ph type="title"/>
+          </p:nvPr>
+        </p:nvSpPr>
+        <p:spPr/>
+        <p:txBody>
+          <a:bodyPr/>
+          <a:lstStyle/>
+          <a:p>
+            <a:r>
+              <a:rPr lang="it-IT" dirty="0" err="1"/>
+              <a:t>LOAd</a:t>
+            </a:r>
+            <a:r>
+              <a:rPr lang="it-IT" dirty="0"/>
+              <a:t> test con endpoint </a:t>
+            </a:r>
+            <a:r>
+              <a:rPr lang="it-IT" dirty="0" err="1"/>
+              <a:t>fastapi</a:t>
+            </a:r>
+            <a:endParaRPr lang="en-GB" dirty="0"/>
+          </a:p>
+        </p:txBody>
+      </p:sp>
+      <p:sp>
+        <p:nvSpPr>
+          <p:cNvPr id="3" name="Content Placeholder 2">
+            <a:extLst>
+              <a:ext uri="{FF2B5EF4-FFF2-40B4-BE49-F238E27FC236}">
+                <a16:creationId xmlns:a16="http://schemas.microsoft.com/office/drawing/2014/main" id="{AF63E86A-01D2-7699-8636-267948E8D747}"/>
+              </a:ext>
+            </a:extLst>
+          </p:cNvPr>
+          <p:cNvSpPr>
+            <a:spLocks noGrp="1"/>
+          </p:cNvSpPr>
+          <p:nvPr>
+            <p:ph idx="1"/>
+          </p:nvPr>
+        </p:nvSpPr>
+        <p:spPr/>
+        <p:txBody>
+          <a:bodyPr/>
+          <a:lstStyle/>
+          <a:p>
+            <a:pPr marL="0" indent="0">
+              <a:buNone/>
+            </a:pPr>
+            <a:r>
+              <a:rPr lang="it-IT" dirty="0">
+                <a:solidFill>
+                  <a:schemeClr val="tx1"/>
+                </a:solidFill>
+              </a:rPr>
+              <a:t>Per poter testare il modello sottoposto a un carico crescente di richieste bisogna creare un endpoint che possa esporlo e renderlo accessibile. Si è proceduto inizialmente utilizzando un percorso in locale e specificando la porta 8081, consentendo di inviare richieste HTTP al miglior modello preso in considerazione (l’originale). </a:t>
+            </a:r>
+            <a:endParaRPr lang="en-GB" dirty="0">
+              <a:solidFill>
+                <a:schemeClr val="tx1"/>
+              </a:solidFill>
+            </a:endParaRPr>
+          </a:p>
+        </p:txBody>
+      </p:sp>
+    </p:spTree>
+    <p:extLst>
+      <p:ext uri="{BB962C8B-B14F-4D97-AF65-F5344CB8AC3E}">
+        <p14:creationId xmlns:p14="http://schemas.microsoft.com/office/powerpoint/2010/main" val="1107276542"/>
+      </p:ext>
+    </p:extLst>
+  </p:cSld>
+  <p:clrMapOvr>
+    <a:masterClrMapping/>
+  </p:clrMapOvr>
+</p:sld>
+</file>
+
+<file path=ppt/slides/slide19.xml><?xml version="1.0" encoding="utf-8"?>
+<p:sld xmlns:a="http://schemas.openxmlformats.org/drawingml/2006/main" xmlns:r="http://schemas.openxmlformats.org/officeDocument/2006/relationships" xmlns:p="http://schemas.openxmlformats.org/presentationml/2006/main">
+  <p:cSld>
+    <p:spTree>
+      <p:nvGrpSpPr>
+        <p:cNvPr id="1" name=""/>
+        <p:cNvGrpSpPr/>
+        <p:nvPr/>
+      </p:nvGrpSpPr>
+      <p:grpSpPr>
+        <a:xfrm>
+          <a:off x="0" y="0"/>
+          <a:ext cx="0" cy="0"/>
+          <a:chOff x="0" y="0"/>
+          <a:chExt cx="0" cy="0"/>
+        </a:xfrm>
+      </p:grpSpPr>
+      <p:sp>
+        <p:nvSpPr>
+          <p:cNvPr id="2" name="Title 1">
+            <a:extLst>
+              <a:ext uri="{FF2B5EF4-FFF2-40B4-BE49-F238E27FC236}">
+                <a16:creationId xmlns:a16="http://schemas.microsoft.com/office/drawing/2014/main" id="{E9ED1417-4A6D-96DC-281C-E055652AD41B}"/>
+              </a:ext>
+            </a:extLst>
+          </p:cNvPr>
+          <p:cNvSpPr>
+            <a:spLocks noGrp="1"/>
+          </p:cNvSpPr>
+          <p:nvPr>
+            <p:ph type="title"/>
+          </p:nvPr>
+        </p:nvSpPr>
+        <p:spPr/>
+        <p:txBody>
+          <a:bodyPr/>
+          <a:lstStyle/>
+          <a:p>
+            <a:r>
+              <a:rPr lang="it-IT" dirty="0"/>
+              <a:t>SCRIPT PYTHON E </a:t>
+            </a:r>
+            <a:r>
+              <a:rPr lang="it-IT" dirty="0" err="1"/>
+              <a:t>UTILITà</a:t>
+            </a:r>
+            <a:endParaRPr lang="en-GB" dirty="0"/>
+          </a:p>
+        </p:txBody>
+      </p:sp>
+      <p:sp>
+        <p:nvSpPr>
+          <p:cNvPr id="3" name="Content Placeholder 2">
+            <a:extLst>
+              <a:ext uri="{FF2B5EF4-FFF2-40B4-BE49-F238E27FC236}">
+                <a16:creationId xmlns:a16="http://schemas.microsoft.com/office/drawing/2014/main" id="{EB9EB5B8-5019-6FBA-FA89-BC68A452F445}"/>
+              </a:ext>
+            </a:extLst>
+          </p:cNvPr>
+          <p:cNvSpPr>
+            <a:spLocks noGrp="1"/>
+          </p:cNvSpPr>
+          <p:nvPr>
+            <p:ph idx="1"/>
+          </p:nvPr>
+        </p:nvSpPr>
+        <p:spPr/>
+        <p:txBody>
+          <a:bodyPr>
+            <a:normAutofit lnSpcReduction="10000"/>
+          </a:bodyPr>
+          <a:lstStyle/>
+          <a:p>
+            <a:pPr marL="0" indent="0">
+              <a:buNone/>
+            </a:pPr>
+            <a:r>
+              <a:rPr lang="it-IT" dirty="0">
+                <a:solidFill>
+                  <a:schemeClr val="tx1"/>
+                </a:solidFill>
+              </a:rPr>
+              <a:t>Di seguito i file utili allo scopo e la loro funzione:</a:t>
+            </a:r>
+          </a:p>
+          <a:p>
+            <a:r>
+              <a:rPr lang="it-IT" dirty="0">
+                <a:solidFill>
+                  <a:schemeClr val="tx1"/>
+                </a:solidFill>
+              </a:rPr>
+              <a:t>engine.py: logica dietro il load testing</a:t>
+            </a:r>
+          </a:p>
+          <a:p>
+            <a:r>
+              <a:rPr lang="it-IT" dirty="0">
+                <a:solidFill>
+                  <a:schemeClr val="tx1"/>
+                </a:solidFill>
+              </a:rPr>
+              <a:t>http_transport.py: creazione del client http, si appoggia a </a:t>
+            </a:r>
+            <a:r>
+              <a:rPr lang="it-IT" dirty="0" err="1">
+                <a:solidFill>
+                  <a:schemeClr val="tx1"/>
+                </a:solidFill>
+              </a:rPr>
+              <a:t>aiohttp</a:t>
+            </a:r>
+            <a:endParaRPr lang="it-IT" dirty="0">
+              <a:solidFill>
+                <a:schemeClr val="tx1"/>
+              </a:solidFill>
+            </a:endParaRPr>
+          </a:p>
+          <a:p>
+            <a:r>
+              <a:rPr lang="it-IT" dirty="0">
+                <a:solidFill>
+                  <a:schemeClr val="tx1"/>
+                </a:solidFill>
+              </a:rPr>
+              <a:t>request_builder.py: creazione del client tramite quello generato da http_transport.py e del payload da inviare al modello</a:t>
+            </a:r>
+          </a:p>
+          <a:p>
+            <a:r>
+              <a:rPr lang="it-IT" dirty="0">
+                <a:solidFill>
+                  <a:schemeClr val="tx1"/>
+                </a:solidFill>
+              </a:rPr>
+              <a:t>endpoint.py: creazione dell’endpoint per il modello</a:t>
+            </a:r>
+          </a:p>
+          <a:p>
+            <a:r>
+              <a:rPr lang="it-IT" dirty="0">
+                <a:solidFill>
+                  <a:schemeClr val="tx1"/>
+                </a:solidFill>
+              </a:rPr>
+              <a:t>load_test.py: esecuzione del test di carico verso l’endpoint specificato</a:t>
+            </a:r>
+          </a:p>
+          <a:p>
+            <a:r>
+              <a:rPr lang="it-IT" dirty="0" err="1">
+                <a:solidFill>
+                  <a:schemeClr val="tx1"/>
+                </a:solidFill>
+              </a:rPr>
+              <a:t>config.yaml</a:t>
+            </a:r>
+            <a:r>
+              <a:rPr lang="it-IT" dirty="0">
+                <a:solidFill>
+                  <a:schemeClr val="tx1"/>
+                </a:solidFill>
+              </a:rPr>
+              <a:t>: dettagli sul test di carico</a:t>
+            </a:r>
+            <a:endParaRPr lang="en-GB" dirty="0">
+              <a:solidFill>
+                <a:schemeClr val="tx1"/>
+              </a:solidFill>
+            </a:endParaRPr>
+          </a:p>
+        </p:txBody>
+      </p:sp>
+    </p:spTree>
+    <p:extLst>
+      <p:ext uri="{BB962C8B-B14F-4D97-AF65-F5344CB8AC3E}">
+        <p14:creationId xmlns:p14="http://schemas.microsoft.com/office/powerpoint/2010/main" val="1425410748"/>
       </p:ext>
     </p:extLst>
   </p:cSld>
@@ -12917,6 +13515,105 @@
     <p:extLst>
       <p:ext uri="{BB962C8B-B14F-4D97-AF65-F5344CB8AC3E}">
         <p14:creationId xmlns:p14="http://schemas.microsoft.com/office/powerpoint/2010/main" val="2110771667"/>
+      </p:ext>
+    </p:extLst>
+  </p:cSld>
+  <p:clrMapOvr>
+    <a:masterClrMapping/>
+  </p:clrMapOvr>
+</p:sld>
+</file>
+
+<file path=ppt/slides/slide20.xml><?xml version="1.0" encoding="utf-8"?>
+<p:sld xmlns:a="http://schemas.openxmlformats.org/drawingml/2006/main" xmlns:r="http://schemas.openxmlformats.org/officeDocument/2006/relationships" xmlns:p="http://schemas.openxmlformats.org/presentationml/2006/main">
+  <p:cSld>
+    <p:spTree>
+      <p:nvGrpSpPr>
+        <p:cNvPr id="1" name=""/>
+        <p:cNvGrpSpPr/>
+        <p:nvPr/>
+      </p:nvGrpSpPr>
+      <p:grpSpPr>
+        <a:xfrm>
+          <a:off x="0" y="0"/>
+          <a:ext cx="0" cy="0"/>
+          <a:chOff x="0" y="0"/>
+          <a:chExt cx="0" cy="0"/>
+        </a:xfrm>
+      </p:grpSpPr>
+      <p:sp>
+        <p:nvSpPr>
+          <p:cNvPr id="2" name="Title 1">
+            <a:extLst>
+              <a:ext uri="{FF2B5EF4-FFF2-40B4-BE49-F238E27FC236}">
+                <a16:creationId xmlns:a16="http://schemas.microsoft.com/office/drawing/2014/main" id="{505858B3-1DCA-C160-3137-DE588E63DCDD}"/>
+              </a:ext>
+            </a:extLst>
+          </p:cNvPr>
+          <p:cNvSpPr>
+            <a:spLocks noGrp="1"/>
+          </p:cNvSpPr>
+          <p:nvPr>
+            <p:ph type="title"/>
+          </p:nvPr>
+        </p:nvSpPr>
+        <p:spPr/>
+        <p:txBody>
+          <a:bodyPr/>
+          <a:lstStyle/>
+          <a:p>
+            <a:r>
+              <a:rPr lang="it-IT" dirty="0"/>
+              <a:t>RISULTATI</a:t>
+            </a:r>
+            <a:endParaRPr lang="en-GB" dirty="0"/>
+          </a:p>
+        </p:txBody>
+      </p:sp>
+      <p:sp>
+        <p:nvSpPr>
+          <p:cNvPr id="3" name="Content Placeholder 2">
+            <a:extLst>
+              <a:ext uri="{FF2B5EF4-FFF2-40B4-BE49-F238E27FC236}">
+                <a16:creationId xmlns:a16="http://schemas.microsoft.com/office/drawing/2014/main" id="{63E42B70-9C7B-0387-D125-C963B866DCE4}"/>
+              </a:ext>
+            </a:extLst>
+          </p:cNvPr>
+          <p:cNvSpPr>
+            <a:spLocks noGrp="1"/>
+          </p:cNvSpPr>
+          <p:nvPr>
+            <p:ph idx="1"/>
+          </p:nvPr>
+        </p:nvSpPr>
+        <p:spPr/>
+        <p:txBody>
+          <a:bodyPr/>
+          <a:lstStyle/>
+          <a:p>
+            <a:pPr marL="0" indent="0">
+              <a:buNone/>
+            </a:pPr>
+            <a:r>
+              <a:rPr lang="it-IT" dirty="0">
+                <a:solidFill>
+                  <a:schemeClr val="tx1"/>
+                </a:solidFill>
+              </a:rPr>
+              <a:t>Di seguito i risultati ottenuti </a:t>
+            </a:r>
+            <a:endParaRPr lang="en-GB" dirty="0">
+              <a:solidFill>
+                <a:schemeClr val="tx1"/>
+              </a:solidFill>
+            </a:endParaRPr>
+          </a:p>
+        </p:txBody>
+      </p:sp>
+    </p:spTree>
+    <p:extLst>
+      <p:ext uri="{BB962C8B-B14F-4D97-AF65-F5344CB8AC3E}">
+        <p14:creationId xmlns:p14="http://schemas.microsoft.com/office/powerpoint/2010/main" val="328842838"/>
       </p:ext>
     </p:extLst>
   </p:cSld>

</xml_diff>

<commit_message>
Update: adding a new endpoint to the ONNX version of the model
</commit_message>
<xml_diff>
--- a/Gsasrec.pptx
+++ b/Gsasrec.pptx
@@ -13600,8 +13600,13 @@
                   <a:schemeClr val="tx1"/>
                 </a:solidFill>
               </a:rPr>
-              <a:t>Di seguito i risultati ottenuti </a:t>
-            </a:r>
+              <a:t>Di seguito i risultati ottenuti:</a:t>
+            </a:r>
+          </a:p>
+          <a:p>
+            <a:pPr marL="0" indent="0">
+              <a:buNone/>
+            </a:pPr>
             <a:endParaRPr lang="en-GB" dirty="0">
               <a:solidFill>
                 <a:schemeClr val="tx1"/>

</xml_diff>

<commit_message>
Update: new values for the config for the load test
</commit_message>
<xml_diff>
--- a/Gsasrec.pptx
+++ b/Gsasrec.pptx
@@ -6153,7 +6153,7 @@
           <a:p>
             <a:fld id="{842CECD3-3569-4D6E-AA1B-67789CA6B4B3}" type="datetimeFigureOut">
               <a:rPr lang="en-GB" smtClean="0"/>
-              <a:t>05/05/2026</a:t>
+              <a:t>08/05/2026</a:t>
             </a:fld>
             <a:endParaRPr lang="en-GB"/>
           </a:p>
@@ -6589,7 +6589,7 @@
           <a:p>
             <a:fld id="{842CECD3-3569-4D6E-AA1B-67789CA6B4B3}" type="datetimeFigureOut">
               <a:rPr lang="en-GB" smtClean="0"/>
-              <a:t>05/05/2026</a:t>
+              <a:t>08/05/2026</a:t>
             </a:fld>
             <a:endParaRPr lang="en-GB"/>
           </a:p>
@@ -6839,7 +6839,7 @@
           <a:p>
             <a:fld id="{842CECD3-3569-4D6E-AA1B-67789CA6B4B3}" type="datetimeFigureOut">
               <a:rPr lang="en-GB" smtClean="0"/>
-              <a:t>05/05/2026</a:t>
+              <a:t>08/05/2026</a:t>
             </a:fld>
             <a:endParaRPr lang="en-GB"/>
           </a:p>
@@ -7147,7 +7147,7 @@
           <a:p>
             <a:fld id="{842CECD3-3569-4D6E-AA1B-67789CA6B4B3}" type="datetimeFigureOut">
               <a:rPr lang="en-GB" smtClean="0"/>
-              <a:t>05/05/2026</a:t>
+              <a:t>08/05/2026</a:t>
             </a:fld>
             <a:endParaRPr lang="en-GB"/>
           </a:p>
@@ -7465,7 +7465,7 @@
           <a:p>
             <a:fld id="{842CECD3-3569-4D6E-AA1B-67789CA6B4B3}" type="datetimeFigureOut">
               <a:rPr lang="en-GB" smtClean="0"/>
-              <a:t>05/05/2026</a:t>
+              <a:t>08/05/2026</a:t>
             </a:fld>
             <a:endParaRPr lang="en-GB"/>
           </a:p>
@@ -7767,7 +7767,7 @@
           <a:p>
             <a:fld id="{842CECD3-3569-4D6E-AA1B-67789CA6B4B3}" type="datetimeFigureOut">
               <a:rPr lang="en-GB" smtClean="0"/>
-              <a:t>05/05/2026</a:t>
+              <a:t>08/05/2026</a:t>
             </a:fld>
             <a:endParaRPr lang="en-GB"/>
           </a:p>
@@ -8134,7 +8134,7 @@
           <a:p>
             <a:fld id="{842CECD3-3569-4D6E-AA1B-67789CA6B4B3}" type="datetimeFigureOut">
               <a:rPr lang="en-GB" smtClean="0"/>
-              <a:t>05/05/2026</a:t>
+              <a:t>08/05/2026</a:t>
             </a:fld>
             <a:endParaRPr lang="en-GB"/>
           </a:p>
@@ -8308,7 +8308,7 @@
           <a:p>
             <a:fld id="{842CECD3-3569-4D6E-AA1B-67789CA6B4B3}" type="datetimeFigureOut">
               <a:rPr lang="en-GB" smtClean="0"/>
-              <a:t>05/05/2026</a:t>
+              <a:t>08/05/2026</a:t>
             </a:fld>
             <a:endParaRPr lang="en-GB"/>
           </a:p>
@@ -8488,7 +8488,7 @@
           <a:p>
             <a:fld id="{842CECD3-3569-4D6E-AA1B-67789CA6B4B3}" type="datetimeFigureOut">
               <a:rPr lang="en-GB" smtClean="0"/>
-              <a:t>05/05/2026</a:t>
+              <a:t>08/05/2026</a:t>
             </a:fld>
             <a:endParaRPr lang="en-GB"/>
           </a:p>
@@ -8658,7 +8658,7 @@
           <a:p>
             <a:fld id="{842CECD3-3569-4D6E-AA1B-67789CA6B4B3}" type="datetimeFigureOut">
               <a:rPr lang="en-GB" smtClean="0"/>
-              <a:t>05/05/2026</a:t>
+              <a:t>08/05/2026</a:t>
             </a:fld>
             <a:endParaRPr lang="en-GB"/>
           </a:p>
@@ -8908,7 +8908,7 @@
           <a:p>
             <a:fld id="{842CECD3-3569-4D6E-AA1B-67789CA6B4B3}" type="datetimeFigureOut">
               <a:rPr lang="en-GB" smtClean="0"/>
-              <a:t>05/05/2026</a:t>
+              <a:t>08/05/2026</a:t>
             </a:fld>
             <a:endParaRPr lang="en-GB"/>
           </a:p>
@@ -9144,7 +9144,7 @@
           <a:p>
             <a:fld id="{842CECD3-3569-4D6E-AA1B-67789CA6B4B3}" type="datetimeFigureOut">
               <a:rPr lang="en-GB" smtClean="0"/>
-              <a:t>05/05/2026</a:t>
+              <a:t>08/05/2026</a:t>
             </a:fld>
             <a:endParaRPr lang="en-GB"/>
           </a:p>
@@ -9526,7 +9526,7 @@
           <a:p>
             <a:fld id="{842CECD3-3569-4D6E-AA1B-67789CA6B4B3}" type="datetimeFigureOut">
               <a:rPr lang="en-GB" smtClean="0"/>
-              <a:t>05/05/2026</a:t>
+              <a:t>08/05/2026</a:t>
             </a:fld>
             <a:endParaRPr lang="en-GB"/>
           </a:p>
@@ -9644,7 +9644,7 @@
           <a:p>
             <a:fld id="{842CECD3-3569-4D6E-AA1B-67789CA6B4B3}" type="datetimeFigureOut">
               <a:rPr lang="en-GB" smtClean="0"/>
-              <a:t>05/05/2026</a:t>
+              <a:t>08/05/2026</a:t>
             </a:fld>
             <a:endParaRPr lang="en-GB"/>
           </a:p>
@@ -9739,7 +9739,7 @@
           <a:p>
             <a:fld id="{842CECD3-3569-4D6E-AA1B-67789CA6B4B3}" type="datetimeFigureOut">
               <a:rPr lang="en-GB" smtClean="0"/>
-              <a:t>05/05/2026</a:t>
+              <a:t>08/05/2026</a:t>
             </a:fld>
             <a:endParaRPr lang="en-GB"/>
           </a:p>
@@ -9994,7 +9994,7 @@
           <a:p>
             <a:fld id="{842CECD3-3569-4D6E-AA1B-67789CA6B4B3}" type="datetimeFigureOut">
               <a:rPr lang="en-GB" smtClean="0"/>
-              <a:t>05/05/2026</a:t>
+              <a:t>08/05/2026</a:t>
             </a:fld>
             <a:endParaRPr lang="en-GB"/>
           </a:p>
@@ -10277,7 +10277,7 @@
           <a:p>
             <a:fld id="{842CECD3-3569-4D6E-AA1B-67789CA6B4B3}" type="datetimeFigureOut">
               <a:rPr lang="en-GB" smtClean="0"/>
-              <a:t>05/05/2026</a:t>
+              <a:t>08/05/2026</a:t>
             </a:fld>
             <a:endParaRPr lang="en-GB"/>
           </a:p>
@@ -10683,7 +10683,7 @@
           <a:p>
             <a:fld id="{842CECD3-3569-4D6E-AA1B-67789CA6B4B3}" type="datetimeFigureOut">
               <a:rPr lang="en-GB" smtClean="0"/>
-              <a:t>05/05/2026</a:t>
+              <a:t>08/05/2026</a:t>
             </a:fld>
             <a:endParaRPr lang="en-GB"/>
           </a:p>
@@ -13002,7 +13002,23 @@
                   <a:schemeClr val="tx1"/>
                 </a:solidFill>
               </a:rPr>
-              <a:t>Per poter testare il modello sottoposto a un carico crescente di richieste bisogna creare un endpoint che possa esporlo e renderlo accessibile. Si è proceduto inizialmente utilizzando un percorso in locale e specificando la porta 8081, consentendo di inviare richieste HTTP al miglior modello preso in considerazione (l’originale). </a:t>
+              <a:t>Per poter testare il modello sottoposto a un carico crescente di richieste bisogna creare un endpoint che possa esporlo e renderlo accessibile. Si è proceduto inizialmente utilizzando un percorso in locale e specificando la porta 8081, consentendo di inviare richieste HTTP al miglior modello preso in considerazione (l’originale). Successivamente si è deciso di creare un secondo endpoint per sfruttare il modello </a:t>
+            </a:r>
+            <a:r>
+              <a:rPr lang="it-IT" dirty="0" err="1">
+                <a:solidFill>
+                  <a:schemeClr val="tx1"/>
+                </a:solidFill>
+              </a:rPr>
+              <a:t>onnx</a:t>
+            </a:r>
+            <a:r>
+              <a:rPr lang="it-IT" dirty="0">
+                <a:solidFill>
+                  <a:schemeClr val="tx1"/>
+                </a:solidFill>
+              </a:rPr>
+              <a:t> e testarlo.</a:t>
             </a:r>
             <a:endParaRPr lang="en-GB" dirty="0">
               <a:solidFill>
@@ -13564,7 +13580,7 @@
           <a:p>
             <a:r>
               <a:rPr lang="it-IT" dirty="0"/>
-              <a:t>RISULTATI</a:t>
+              <a:t>VALORI DI CONFIGURAZIONE</a:t>
             </a:r>
             <a:endParaRPr lang="en-GB" dirty="0"/>
           </a:p>
@@ -13591,22 +13607,77 @@
           <a:bodyPr/>
           <a:lstStyle/>
           <a:p>
-            <a:pPr marL="0" indent="0">
-              <a:buNone/>
-            </a:pPr>
+            <a:r>
+              <a:rPr lang="it-IT" dirty="0" err="1">
+                <a:solidFill>
+                  <a:schemeClr val="tx1"/>
+                </a:solidFill>
+              </a:rPr>
+              <a:t>target_rps</a:t>
+            </a:r>
             <a:r>
               <a:rPr lang="it-IT" dirty="0">
                 <a:solidFill>
                   <a:schemeClr val="tx1"/>
                 </a:solidFill>
               </a:rPr>
-              <a:t>Di seguito i risultati ottenuti:</a:t>
-            </a:r>
-          </a:p>
-          <a:p>
-            <a:pPr marL="0" indent="0">
-              <a:buNone/>
-            </a:pPr>
+              <a:t>: [10, 50, 150, 300, 600, 1000]</a:t>
+            </a:r>
+          </a:p>
+          <a:p>
+            <a:r>
+              <a:rPr lang="it-IT" dirty="0" err="1">
+                <a:solidFill>
+                  <a:schemeClr val="tx1"/>
+                </a:solidFill>
+              </a:rPr>
+              <a:t>duration_seconds</a:t>
+            </a:r>
+            <a:r>
+              <a:rPr lang="it-IT" dirty="0">
+                <a:solidFill>
+                  <a:schemeClr val="tx1"/>
+                </a:solidFill>
+              </a:rPr>
+              <a:t>: 60</a:t>
+            </a:r>
+          </a:p>
+          <a:p>
+            <a:r>
+              <a:rPr lang="it-IT" dirty="0" err="1">
+                <a:solidFill>
+                  <a:schemeClr val="tx1"/>
+                </a:solidFill>
+              </a:rPr>
+              <a:t>num_clients</a:t>
+            </a:r>
+            <a:r>
+              <a:rPr lang="it-IT" dirty="0">
+                <a:solidFill>
+                  <a:schemeClr val="tx1"/>
+                </a:solidFill>
+              </a:rPr>
+              <a:t>: 32</a:t>
+            </a:r>
+          </a:p>
+          <a:p>
+            <a:r>
+              <a:rPr lang="it-IT" dirty="0">
+                <a:solidFill>
+                  <a:schemeClr val="tx1"/>
+                </a:solidFill>
+              </a:rPr>
+              <a:t>Macchina utilizzata:</a:t>
+            </a:r>
+          </a:p>
+          <a:p>
+            <a:endParaRPr lang="it-IT" dirty="0">
+              <a:solidFill>
+                <a:schemeClr val="tx1"/>
+              </a:solidFill>
+            </a:endParaRPr>
+          </a:p>
+          <a:p>
             <a:endParaRPr lang="en-GB" dirty="0">
               <a:solidFill>
                 <a:schemeClr val="tx1"/>

</xml_diff>

<commit_message>
Update: put the onnx model on the gpu
</commit_message>
<xml_diff>
--- a/Gsasrec.pptx
+++ b/Gsasrec.pptx
@@ -25,6 +25,8 @@
     <p:sldId id="273" r:id="rId19"/>
     <p:sldId id="274" r:id="rId20"/>
     <p:sldId id="275" r:id="rId21"/>
+    <p:sldId id="276" r:id="rId22"/>
+    <p:sldId id="277" r:id="rId23"/>
   </p:sldIdLst>
   <p:sldSz cx="12192000" cy="6858000"/>
   <p:notesSz cx="6858000" cy="9144000"/>
@@ -6153,7 +6155,7 @@
           <a:p>
             <a:fld id="{842CECD3-3569-4D6E-AA1B-67789CA6B4B3}" type="datetimeFigureOut">
               <a:rPr lang="en-GB" smtClean="0"/>
-              <a:t>08/05/2026</a:t>
+              <a:t>11/05/2026</a:t>
             </a:fld>
             <a:endParaRPr lang="en-GB"/>
           </a:p>
@@ -6589,7 +6591,7 @@
           <a:p>
             <a:fld id="{842CECD3-3569-4D6E-AA1B-67789CA6B4B3}" type="datetimeFigureOut">
               <a:rPr lang="en-GB" smtClean="0"/>
-              <a:t>08/05/2026</a:t>
+              <a:t>11/05/2026</a:t>
             </a:fld>
             <a:endParaRPr lang="en-GB"/>
           </a:p>
@@ -6839,7 +6841,7 @@
           <a:p>
             <a:fld id="{842CECD3-3569-4D6E-AA1B-67789CA6B4B3}" type="datetimeFigureOut">
               <a:rPr lang="en-GB" smtClean="0"/>
-              <a:t>08/05/2026</a:t>
+              <a:t>11/05/2026</a:t>
             </a:fld>
             <a:endParaRPr lang="en-GB"/>
           </a:p>
@@ -7147,7 +7149,7 @@
           <a:p>
             <a:fld id="{842CECD3-3569-4D6E-AA1B-67789CA6B4B3}" type="datetimeFigureOut">
               <a:rPr lang="en-GB" smtClean="0"/>
-              <a:t>08/05/2026</a:t>
+              <a:t>11/05/2026</a:t>
             </a:fld>
             <a:endParaRPr lang="en-GB"/>
           </a:p>
@@ -7465,7 +7467,7 @@
           <a:p>
             <a:fld id="{842CECD3-3569-4D6E-AA1B-67789CA6B4B3}" type="datetimeFigureOut">
               <a:rPr lang="en-GB" smtClean="0"/>
-              <a:t>08/05/2026</a:t>
+              <a:t>11/05/2026</a:t>
             </a:fld>
             <a:endParaRPr lang="en-GB"/>
           </a:p>
@@ -7767,7 +7769,7 @@
           <a:p>
             <a:fld id="{842CECD3-3569-4D6E-AA1B-67789CA6B4B3}" type="datetimeFigureOut">
               <a:rPr lang="en-GB" smtClean="0"/>
-              <a:t>08/05/2026</a:t>
+              <a:t>11/05/2026</a:t>
             </a:fld>
             <a:endParaRPr lang="en-GB"/>
           </a:p>
@@ -8134,7 +8136,7 @@
           <a:p>
             <a:fld id="{842CECD3-3569-4D6E-AA1B-67789CA6B4B3}" type="datetimeFigureOut">
               <a:rPr lang="en-GB" smtClean="0"/>
-              <a:t>08/05/2026</a:t>
+              <a:t>11/05/2026</a:t>
             </a:fld>
             <a:endParaRPr lang="en-GB"/>
           </a:p>
@@ -8308,7 +8310,7 @@
           <a:p>
             <a:fld id="{842CECD3-3569-4D6E-AA1B-67789CA6B4B3}" type="datetimeFigureOut">
               <a:rPr lang="en-GB" smtClean="0"/>
-              <a:t>08/05/2026</a:t>
+              <a:t>11/05/2026</a:t>
             </a:fld>
             <a:endParaRPr lang="en-GB"/>
           </a:p>
@@ -8488,7 +8490,7 @@
           <a:p>
             <a:fld id="{842CECD3-3569-4D6E-AA1B-67789CA6B4B3}" type="datetimeFigureOut">
               <a:rPr lang="en-GB" smtClean="0"/>
-              <a:t>08/05/2026</a:t>
+              <a:t>11/05/2026</a:t>
             </a:fld>
             <a:endParaRPr lang="en-GB"/>
           </a:p>
@@ -8658,7 +8660,7 @@
           <a:p>
             <a:fld id="{842CECD3-3569-4D6E-AA1B-67789CA6B4B3}" type="datetimeFigureOut">
               <a:rPr lang="en-GB" smtClean="0"/>
-              <a:t>08/05/2026</a:t>
+              <a:t>11/05/2026</a:t>
             </a:fld>
             <a:endParaRPr lang="en-GB"/>
           </a:p>
@@ -8908,7 +8910,7 @@
           <a:p>
             <a:fld id="{842CECD3-3569-4D6E-AA1B-67789CA6B4B3}" type="datetimeFigureOut">
               <a:rPr lang="en-GB" smtClean="0"/>
-              <a:t>08/05/2026</a:t>
+              <a:t>11/05/2026</a:t>
             </a:fld>
             <a:endParaRPr lang="en-GB"/>
           </a:p>
@@ -9144,7 +9146,7 @@
           <a:p>
             <a:fld id="{842CECD3-3569-4D6E-AA1B-67789CA6B4B3}" type="datetimeFigureOut">
               <a:rPr lang="en-GB" smtClean="0"/>
-              <a:t>08/05/2026</a:t>
+              <a:t>11/05/2026</a:t>
             </a:fld>
             <a:endParaRPr lang="en-GB"/>
           </a:p>
@@ -9526,7 +9528,7 @@
           <a:p>
             <a:fld id="{842CECD3-3569-4D6E-AA1B-67789CA6B4B3}" type="datetimeFigureOut">
               <a:rPr lang="en-GB" smtClean="0"/>
-              <a:t>08/05/2026</a:t>
+              <a:t>11/05/2026</a:t>
             </a:fld>
             <a:endParaRPr lang="en-GB"/>
           </a:p>
@@ -9644,7 +9646,7 @@
           <a:p>
             <a:fld id="{842CECD3-3569-4D6E-AA1B-67789CA6B4B3}" type="datetimeFigureOut">
               <a:rPr lang="en-GB" smtClean="0"/>
-              <a:t>08/05/2026</a:t>
+              <a:t>11/05/2026</a:t>
             </a:fld>
             <a:endParaRPr lang="en-GB"/>
           </a:p>
@@ -9739,7 +9741,7 @@
           <a:p>
             <a:fld id="{842CECD3-3569-4D6E-AA1B-67789CA6B4B3}" type="datetimeFigureOut">
               <a:rPr lang="en-GB" smtClean="0"/>
-              <a:t>08/05/2026</a:t>
+              <a:t>11/05/2026</a:t>
             </a:fld>
             <a:endParaRPr lang="en-GB"/>
           </a:p>
@@ -9994,7 +9996,7 @@
           <a:p>
             <a:fld id="{842CECD3-3569-4D6E-AA1B-67789CA6B4B3}" type="datetimeFigureOut">
               <a:rPr lang="en-GB" smtClean="0"/>
-              <a:t>08/05/2026</a:t>
+              <a:t>11/05/2026</a:t>
             </a:fld>
             <a:endParaRPr lang="en-GB"/>
           </a:p>
@@ -10277,7 +10279,7 @@
           <a:p>
             <a:fld id="{842CECD3-3569-4D6E-AA1B-67789CA6B4B3}" type="datetimeFigureOut">
               <a:rPr lang="en-GB" smtClean="0"/>
-              <a:t>08/05/2026</a:t>
+              <a:t>11/05/2026</a:t>
             </a:fld>
             <a:endParaRPr lang="en-GB"/>
           </a:p>
@@ -10683,7 +10685,7 @@
           <a:p>
             <a:fld id="{842CECD3-3569-4D6E-AA1B-67789CA6B4B3}" type="datetimeFigureOut">
               <a:rPr lang="en-GB" smtClean="0"/>
-              <a:t>08/05/2026</a:t>
+              <a:t>11/05/2026</a:t>
             </a:fld>
             <a:endParaRPr lang="en-GB"/>
           </a:p>
@@ -13667,8 +13669,43 @@
                   <a:schemeClr val="tx1"/>
                 </a:solidFill>
               </a:rPr>
-              <a:t>Macchina utilizzata:</a:t>
-            </a:r>
+              <a:t>GPU: RTX A4500</a:t>
+            </a:r>
+          </a:p>
+          <a:p>
+            <a:r>
+              <a:rPr lang="it-IT" dirty="0" err="1">
+                <a:solidFill>
+                  <a:schemeClr val="tx1"/>
+                </a:solidFill>
+              </a:rPr>
+              <a:t>vCPU</a:t>
+            </a:r>
+            <a:r>
+              <a:rPr lang="it-IT" dirty="0">
+                <a:solidFill>
+                  <a:schemeClr val="tx1"/>
+                </a:solidFill>
+              </a:rPr>
+              <a:t>: 12 (AMD EPYC 7352 24-Core Processor)</a:t>
+            </a:r>
+          </a:p>
+          <a:p>
+            <a:r>
+              <a:rPr lang="it-IT" dirty="0">
+                <a:solidFill>
+                  <a:schemeClr val="tx1"/>
+                </a:solidFill>
+              </a:rPr>
+              <a:t>Memoria: 62 GB</a:t>
+            </a:r>
+          </a:p>
+          <a:p>
+            <a:endParaRPr lang="it-IT" dirty="0">
+              <a:solidFill>
+                <a:schemeClr val="tx1"/>
+              </a:solidFill>
+            </a:endParaRPr>
           </a:p>
           <a:p>
             <a:endParaRPr lang="it-IT" dirty="0">
@@ -13690,6 +13727,1780 @@
     <p:extLst>
       <p:ext uri="{BB962C8B-B14F-4D97-AF65-F5344CB8AC3E}">
         <p14:creationId xmlns:p14="http://schemas.microsoft.com/office/powerpoint/2010/main" val="328842838"/>
+      </p:ext>
+    </p:extLst>
+  </p:cSld>
+  <p:clrMapOvr>
+    <a:masterClrMapping/>
+  </p:clrMapOvr>
+</p:sld>
+</file>
+
+<file path=ppt/slides/slide21.xml><?xml version="1.0" encoding="utf-8"?>
+<p:sld xmlns:a="http://schemas.openxmlformats.org/drawingml/2006/main" xmlns:r="http://schemas.openxmlformats.org/officeDocument/2006/relationships" xmlns:p="http://schemas.openxmlformats.org/presentationml/2006/main">
+  <p:cSld>
+    <p:spTree>
+      <p:nvGrpSpPr>
+        <p:cNvPr id="1" name=""/>
+        <p:cNvGrpSpPr/>
+        <p:nvPr/>
+      </p:nvGrpSpPr>
+      <p:grpSpPr>
+        <a:xfrm>
+          <a:off x="0" y="0"/>
+          <a:ext cx="0" cy="0"/>
+          <a:chOff x="0" y="0"/>
+          <a:chExt cx="0" cy="0"/>
+        </a:xfrm>
+      </p:grpSpPr>
+      <p:sp>
+        <p:nvSpPr>
+          <p:cNvPr id="2" name="Title 1">
+            <a:extLst>
+              <a:ext uri="{FF2B5EF4-FFF2-40B4-BE49-F238E27FC236}">
+                <a16:creationId xmlns:a16="http://schemas.microsoft.com/office/drawing/2014/main" id="{0E71EC63-FDBE-551E-E3D3-7C6632604FA9}"/>
+              </a:ext>
+            </a:extLst>
+          </p:cNvPr>
+          <p:cNvSpPr>
+            <a:spLocks noGrp="1"/>
+          </p:cNvSpPr>
+          <p:nvPr>
+            <p:ph type="title"/>
+          </p:nvPr>
+        </p:nvSpPr>
+        <p:spPr/>
+        <p:txBody>
+          <a:bodyPr/>
+          <a:lstStyle/>
+          <a:p>
+            <a:r>
+              <a:rPr lang="it-IT" dirty="0"/>
+              <a:t>Risultati modello </a:t>
+            </a:r>
+            <a:r>
+              <a:rPr lang="it-IT" dirty="0" err="1"/>
+              <a:t>python</a:t>
+            </a:r>
+            <a:r>
+              <a:rPr lang="it-IT" dirty="0"/>
+              <a:t> nativo</a:t>
+            </a:r>
+            <a:endParaRPr lang="en-GB" dirty="0"/>
+          </a:p>
+        </p:txBody>
+      </p:sp>
+      <p:graphicFrame>
+        <p:nvGraphicFramePr>
+          <p:cNvPr id="4" name="Content Placeholder 3">
+            <a:extLst>
+              <a:ext uri="{FF2B5EF4-FFF2-40B4-BE49-F238E27FC236}">
+                <a16:creationId xmlns:a16="http://schemas.microsoft.com/office/drawing/2014/main" id="{EAF7EEBD-2FFC-53BA-16B5-7BB2B45EFB68}"/>
+              </a:ext>
+            </a:extLst>
+          </p:cNvPr>
+          <p:cNvGraphicFramePr>
+            <a:graphicFrameLocks noGrp="1"/>
+          </p:cNvGraphicFramePr>
+          <p:nvPr>
+            <p:ph idx="1"/>
+            <p:extLst>
+              <p:ext uri="{D42A27DB-BD31-4B8C-83A1-F6EECF244321}">
+                <p14:modId xmlns:p14="http://schemas.microsoft.com/office/powerpoint/2010/main" val="4204520424"/>
+              </p:ext>
+            </p:extLst>
+          </p:nvPr>
+        </p:nvGraphicFramePr>
+        <p:xfrm>
+          <a:off x="684211" y="685800"/>
+          <a:ext cx="9639658" cy="2865120"/>
+        </p:xfrm>
+        <a:graphic>
+          <a:graphicData uri="http://schemas.openxmlformats.org/drawingml/2006/table">
+            <a:tbl>
+              <a:tblPr firstRow="1" bandRow="1">
+                <a:tableStyleId>{5C22544A-7EE6-4342-B048-85BDC9FD1C3A}</a:tableStyleId>
+              </a:tblPr>
+              <a:tblGrid>
+                <a:gridCol w="1377094">
+                  <a:extLst>
+                    <a:ext uri="{9D8B030D-6E8A-4147-A177-3AD203B41FA5}">
+                      <a16:colId xmlns:a16="http://schemas.microsoft.com/office/drawing/2014/main" val="4131664428"/>
+                    </a:ext>
+                  </a:extLst>
+                </a:gridCol>
+                <a:gridCol w="1377094">
+                  <a:extLst>
+                    <a:ext uri="{9D8B030D-6E8A-4147-A177-3AD203B41FA5}">
+                      <a16:colId xmlns:a16="http://schemas.microsoft.com/office/drawing/2014/main" val="2682047389"/>
+                    </a:ext>
+                  </a:extLst>
+                </a:gridCol>
+                <a:gridCol w="1377094">
+                  <a:extLst>
+                    <a:ext uri="{9D8B030D-6E8A-4147-A177-3AD203B41FA5}">
+                      <a16:colId xmlns:a16="http://schemas.microsoft.com/office/drawing/2014/main" val="560020995"/>
+                    </a:ext>
+                  </a:extLst>
+                </a:gridCol>
+                <a:gridCol w="1377094">
+                  <a:extLst>
+                    <a:ext uri="{9D8B030D-6E8A-4147-A177-3AD203B41FA5}">
+                      <a16:colId xmlns:a16="http://schemas.microsoft.com/office/drawing/2014/main" val="2200272610"/>
+                    </a:ext>
+                  </a:extLst>
+                </a:gridCol>
+                <a:gridCol w="1377094">
+                  <a:extLst>
+                    <a:ext uri="{9D8B030D-6E8A-4147-A177-3AD203B41FA5}">
+                      <a16:colId xmlns:a16="http://schemas.microsoft.com/office/drawing/2014/main" val="1594005505"/>
+                    </a:ext>
+                  </a:extLst>
+                </a:gridCol>
+                <a:gridCol w="1377094">
+                  <a:extLst>
+                    <a:ext uri="{9D8B030D-6E8A-4147-A177-3AD203B41FA5}">
+                      <a16:colId xmlns:a16="http://schemas.microsoft.com/office/drawing/2014/main" val="748764634"/>
+                    </a:ext>
+                  </a:extLst>
+                </a:gridCol>
+                <a:gridCol w="1377094">
+                  <a:extLst>
+                    <a:ext uri="{9D8B030D-6E8A-4147-A177-3AD203B41FA5}">
+                      <a16:colId xmlns:a16="http://schemas.microsoft.com/office/drawing/2014/main" val="3172487590"/>
+                    </a:ext>
+                  </a:extLst>
+                </a:gridCol>
+              </a:tblGrid>
+              <a:tr h="370840">
+                <a:tc>
+                  <a:txBody>
+                    <a:bodyPr/>
+                    <a:lstStyle/>
+                    <a:p>
+                      <a:r>
+                        <a:rPr lang="it-IT" dirty="0"/>
+                        <a:t>Target RPS</a:t>
+                      </a:r>
+                      <a:endParaRPr lang="en-GB" dirty="0"/>
+                    </a:p>
+                  </a:txBody>
+                  <a:tcPr/>
+                </a:tc>
+                <a:tc>
+                  <a:txBody>
+                    <a:bodyPr/>
+                    <a:lstStyle/>
+                    <a:p>
+                      <a:r>
+                        <a:rPr lang="it-IT" dirty="0"/>
+                        <a:t>RPS effettivi</a:t>
+                      </a:r>
+                      <a:endParaRPr lang="en-GB" dirty="0"/>
+                    </a:p>
+                  </a:txBody>
+                  <a:tcPr/>
+                </a:tc>
+                <a:tc>
+                  <a:txBody>
+                    <a:bodyPr/>
+                    <a:lstStyle/>
+                    <a:p>
+                      <a:r>
+                        <a:rPr lang="it-IT" dirty="0"/>
+                        <a:t>Media latenze (s)</a:t>
+                      </a:r>
+                      <a:endParaRPr lang="en-GB" dirty="0"/>
+                    </a:p>
+                  </a:txBody>
+                  <a:tcPr/>
+                </a:tc>
+                <a:tc>
+                  <a:txBody>
+                    <a:bodyPr/>
+                    <a:lstStyle/>
+                    <a:p>
+                      <a:r>
+                        <a:rPr lang="it-IT" dirty="0"/>
+                        <a:t>P50 (s)</a:t>
+                      </a:r>
+                      <a:endParaRPr lang="en-GB" dirty="0"/>
+                    </a:p>
+                  </a:txBody>
+                  <a:tcPr/>
+                </a:tc>
+                <a:tc>
+                  <a:txBody>
+                    <a:bodyPr/>
+                    <a:lstStyle/>
+                    <a:p>
+                      <a:r>
+                        <a:rPr lang="it-IT" dirty="0"/>
+                        <a:t>P(90) (s)</a:t>
+                      </a:r>
+                      <a:endParaRPr lang="en-GB" dirty="0"/>
+                    </a:p>
+                  </a:txBody>
+                  <a:tcPr/>
+                </a:tc>
+                <a:tc>
+                  <a:txBody>
+                    <a:bodyPr/>
+                    <a:lstStyle/>
+                    <a:p>
+                      <a:r>
+                        <a:rPr lang="it-IT" dirty="0"/>
+                        <a:t>P(95) (s)</a:t>
+                      </a:r>
+                      <a:endParaRPr lang="en-GB" dirty="0"/>
+                    </a:p>
+                  </a:txBody>
+                  <a:tcPr/>
+                </a:tc>
+                <a:tc>
+                  <a:txBody>
+                    <a:bodyPr/>
+                    <a:lstStyle/>
+                    <a:p>
+                      <a:r>
+                        <a:rPr lang="it-IT" dirty="0"/>
+                        <a:t>P(99) (s)</a:t>
+                      </a:r>
+                      <a:endParaRPr lang="en-GB" dirty="0"/>
+                    </a:p>
+                  </a:txBody>
+                  <a:tcPr/>
+                </a:tc>
+                <a:extLst>
+                  <a:ext uri="{0D108BD9-81ED-4DB2-BD59-A6C34878D82A}">
+                    <a16:rowId xmlns:a16="http://schemas.microsoft.com/office/drawing/2014/main" val="1019616449"/>
+                  </a:ext>
+                </a:extLst>
+              </a:tr>
+              <a:tr h="370840">
+                <a:tc>
+                  <a:txBody>
+                    <a:bodyPr/>
+                    <a:lstStyle/>
+                    <a:p>
+                      <a:r>
+                        <a:rPr lang="it-IT" dirty="0"/>
+                        <a:t>10</a:t>
+                      </a:r>
+                      <a:endParaRPr lang="en-GB" dirty="0"/>
+                    </a:p>
+                  </a:txBody>
+                  <a:tcPr/>
+                </a:tc>
+                <a:tc>
+                  <a:txBody>
+                    <a:bodyPr/>
+                    <a:lstStyle/>
+                    <a:p>
+                      <a:r>
+                        <a:rPr lang="it-IT" dirty="0"/>
+                        <a:t>10,1</a:t>
+                      </a:r>
+                      <a:endParaRPr lang="en-GB" dirty="0"/>
+                    </a:p>
+                  </a:txBody>
+                  <a:tcPr/>
+                </a:tc>
+                <a:tc>
+                  <a:txBody>
+                    <a:bodyPr/>
+                    <a:lstStyle/>
+                    <a:p>
+                      <a:r>
+                        <a:rPr lang="it-IT" dirty="0"/>
+                        <a:t>1,5</a:t>
+                      </a:r>
+                      <a:endParaRPr lang="en-GB" dirty="0"/>
+                    </a:p>
+                  </a:txBody>
+                  <a:tcPr/>
+                </a:tc>
+                <a:tc>
+                  <a:txBody>
+                    <a:bodyPr/>
+                    <a:lstStyle/>
+                    <a:p>
+                      <a:r>
+                        <a:rPr lang="it-IT" dirty="0"/>
+                        <a:t>1,5</a:t>
+                      </a:r>
+                      <a:endParaRPr lang="en-GB" dirty="0"/>
+                    </a:p>
+                  </a:txBody>
+                  <a:tcPr/>
+                </a:tc>
+                <a:tc>
+                  <a:txBody>
+                    <a:bodyPr/>
+                    <a:lstStyle/>
+                    <a:p>
+                      <a:r>
+                        <a:rPr lang="it-IT" dirty="0"/>
+                        <a:t>1,8</a:t>
+                      </a:r>
+                      <a:endParaRPr lang="en-GB" dirty="0"/>
+                    </a:p>
+                  </a:txBody>
+                  <a:tcPr/>
+                </a:tc>
+                <a:tc>
+                  <a:txBody>
+                    <a:bodyPr/>
+                    <a:lstStyle/>
+                    <a:p>
+                      <a:r>
+                        <a:rPr lang="it-IT" dirty="0"/>
+                        <a:t>1,9</a:t>
+                      </a:r>
+                      <a:endParaRPr lang="en-GB" dirty="0"/>
+                    </a:p>
+                  </a:txBody>
+                  <a:tcPr/>
+                </a:tc>
+                <a:tc>
+                  <a:txBody>
+                    <a:bodyPr/>
+                    <a:lstStyle/>
+                    <a:p>
+                      <a:r>
+                        <a:rPr lang="it-IT" dirty="0"/>
+                        <a:t>2,5</a:t>
+                      </a:r>
+                      <a:endParaRPr lang="en-GB" dirty="0"/>
+                    </a:p>
+                  </a:txBody>
+                  <a:tcPr/>
+                </a:tc>
+                <a:extLst>
+                  <a:ext uri="{0D108BD9-81ED-4DB2-BD59-A6C34878D82A}">
+                    <a16:rowId xmlns:a16="http://schemas.microsoft.com/office/drawing/2014/main" val="3033522304"/>
+                  </a:ext>
+                </a:extLst>
+              </a:tr>
+              <a:tr h="370840">
+                <a:tc>
+                  <a:txBody>
+                    <a:bodyPr/>
+                    <a:lstStyle/>
+                    <a:p>
+                      <a:r>
+                        <a:rPr lang="it-IT" dirty="0"/>
+                        <a:t>50</a:t>
+                      </a:r>
+                      <a:endParaRPr lang="en-GB" dirty="0"/>
+                    </a:p>
+                  </a:txBody>
+                  <a:tcPr/>
+                </a:tc>
+                <a:tc>
+                  <a:txBody>
+                    <a:bodyPr/>
+                    <a:lstStyle/>
+                    <a:p>
+                      <a:r>
+                        <a:rPr lang="it-IT" dirty="0"/>
+                        <a:t>49</a:t>
+                      </a:r>
+                      <a:endParaRPr lang="en-GB" dirty="0"/>
+                    </a:p>
+                  </a:txBody>
+                  <a:tcPr/>
+                </a:tc>
+                <a:tc>
+                  <a:txBody>
+                    <a:bodyPr/>
+                    <a:lstStyle/>
+                    <a:p>
+                      <a:r>
+                        <a:rPr lang="it-IT" dirty="0"/>
+                        <a:t>1,4</a:t>
+                      </a:r>
+                      <a:endParaRPr lang="en-GB" dirty="0"/>
+                    </a:p>
+                  </a:txBody>
+                  <a:tcPr/>
+                </a:tc>
+                <a:tc>
+                  <a:txBody>
+                    <a:bodyPr/>
+                    <a:lstStyle/>
+                    <a:p>
+                      <a:r>
+                        <a:rPr lang="it-IT" dirty="0"/>
+                        <a:t>1,2</a:t>
+                      </a:r>
+                      <a:endParaRPr lang="en-GB" dirty="0"/>
+                    </a:p>
+                  </a:txBody>
+                  <a:tcPr/>
+                </a:tc>
+                <a:tc>
+                  <a:txBody>
+                    <a:bodyPr/>
+                    <a:lstStyle/>
+                    <a:p>
+                      <a:r>
+                        <a:rPr lang="it-IT" dirty="0"/>
+                        <a:t>1,7</a:t>
+                      </a:r>
+                      <a:endParaRPr lang="en-GB" dirty="0"/>
+                    </a:p>
+                  </a:txBody>
+                  <a:tcPr/>
+                </a:tc>
+                <a:tc>
+                  <a:txBody>
+                    <a:bodyPr/>
+                    <a:lstStyle/>
+                    <a:p>
+                      <a:r>
+                        <a:rPr lang="it-IT" dirty="0"/>
+                        <a:t>2,1</a:t>
+                      </a:r>
+                      <a:endParaRPr lang="en-GB" dirty="0"/>
+                    </a:p>
+                  </a:txBody>
+                  <a:tcPr/>
+                </a:tc>
+                <a:tc>
+                  <a:txBody>
+                    <a:bodyPr/>
+                    <a:lstStyle/>
+                    <a:p>
+                      <a:r>
+                        <a:rPr lang="it-IT" dirty="0"/>
+                        <a:t>3,2</a:t>
+                      </a:r>
+                      <a:endParaRPr lang="en-GB" dirty="0"/>
+                    </a:p>
+                  </a:txBody>
+                  <a:tcPr/>
+                </a:tc>
+                <a:extLst>
+                  <a:ext uri="{0D108BD9-81ED-4DB2-BD59-A6C34878D82A}">
+                    <a16:rowId xmlns:a16="http://schemas.microsoft.com/office/drawing/2014/main" val="774249562"/>
+                  </a:ext>
+                </a:extLst>
+              </a:tr>
+              <a:tr h="370840">
+                <a:tc>
+                  <a:txBody>
+                    <a:bodyPr/>
+                    <a:lstStyle/>
+                    <a:p>
+                      <a:r>
+                        <a:rPr lang="it-IT" dirty="0"/>
+                        <a:t>150</a:t>
+                      </a:r>
+                      <a:endParaRPr lang="en-GB" dirty="0"/>
+                    </a:p>
+                  </a:txBody>
+                  <a:tcPr/>
+                </a:tc>
+                <a:tc>
+                  <a:txBody>
+                    <a:bodyPr/>
+                    <a:lstStyle/>
+                    <a:p>
+                      <a:r>
+                        <a:rPr lang="it-IT" dirty="0"/>
+                        <a:t>148</a:t>
+                      </a:r>
+                      <a:endParaRPr lang="en-GB" dirty="0"/>
+                    </a:p>
+                  </a:txBody>
+                  <a:tcPr/>
+                </a:tc>
+                <a:tc>
+                  <a:txBody>
+                    <a:bodyPr/>
+                    <a:lstStyle/>
+                    <a:p>
+                      <a:r>
+                        <a:rPr lang="it-IT" dirty="0"/>
+                        <a:t>1,3</a:t>
+                      </a:r>
+                      <a:endParaRPr lang="en-GB" dirty="0"/>
+                    </a:p>
+                  </a:txBody>
+                  <a:tcPr/>
+                </a:tc>
+                <a:tc>
+                  <a:txBody>
+                    <a:bodyPr/>
+                    <a:lstStyle/>
+                    <a:p>
+                      <a:r>
+                        <a:rPr lang="it-IT" dirty="0"/>
+                        <a:t>1,2</a:t>
+                      </a:r>
+                      <a:endParaRPr lang="en-GB" dirty="0"/>
+                    </a:p>
+                  </a:txBody>
+                  <a:tcPr/>
+                </a:tc>
+                <a:tc>
+                  <a:txBody>
+                    <a:bodyPr/>
+                    <a:lstStyle/>
+                    <a:p>
+                      <a:r>
+                        <a:rPr lang="it-IT" dirty="0"/>
+                        <a:t>1,9</a:t>
+                      </a:r>
+                      <a:endParaRPr lang="en-GB" dirty="0"/>
+                    </a:p>
+                  </a:txBody>
+                  <a:tcPr/>
+                </a:tc>
+                <a:tc>
+                  <a:txBody>
+                    <a:bodyPr/>
+                    <a:lstStyle/>
+                    <a:p>
+                      <a:r>
+                        <a:rPr lang="it-IT" dirty="0"/>
+                        <a:t>2,2</a:t>
+                      </a:r>
+                      <a:endParaRPr lang="en-GB" dirty="0"/>
+                    </a:p>
+                  </a:txBody>
+                  <a:tcPr/>
+                </a:tc>
+                <a:tc>
+                  <a:txBody>
+                    <a:bodyPr/>
+                    <a:lstStyle/>
+                    <a:p>
+                      <a:r>
+                        <a:rPr lang="it-IT" dirty="0"/>
+                        <a:t>3,1</a:t>
+                      </a:r>
+                      <a:endParaRPr lang="en-GB" dirty="0"/>
+                    </a:p>
+                  </a:txBody>
+                  <a:tcPr/>
+                </a:tc>
+                <a:extLst>
+                  <a:ext uri="{0D108BD9-81ED-4DB2-BD59-A6C34878D82A}">
+                    <a16:rowId xmlns:a16="http://schemas.microsoft.com/office/drawing/2014/main" val="3093664536"/>
+                  </a:ext>
+                </a:extLst>
+              </a:tr>
+              <a:tr h="370840">
+                <a:tc>
+                  <a:txBody>
+                    <a:bodyPr/>
+                    <a:lstStyle/>
+                    <a:p>
+                      <a:r>
+                        <a:rPr lang="it-IT" dirty="0"/>
+                        <a:t>300</a:t>
+                      </a:r>
+                      <a:endParaRPr lang="en-GB" dirty="0"/>
+                    </a:p>
+                  </a:txBody>
+                  <a:tcPr/>
+                </a:tc>
+                <a:tc>
+                  <a:txBody>
+                    <a:bodyPr/>
+                    <a:lstStyle/>
+                    <a:p>
+                      <a:r>
+                        <a:rPr lang="it-IT" dirty="0"/>
+                        <a:t>292,7</a:t>
+                      </a:r>
+                      <a:endParaRPr lang="en-GB" dirty="0"/>
+                    </a:p>
+                  </a:txBody>
+                  <a:tcPr/>
+                </a:tc>
+                <a:tc>
+                  <a:txBody>
+                    <a:bodyPr/>
+                    <a:lstStyle/>
+                    <a:p>
+                      <a:r>
+                        <a:rPr lang="it-IT" dirty="0"/>
+                        <a:t>1,5</a:t>
+                      </a:r>
+                      <a:endParaRPr lang="en-GB" dirty="0"/>
+                    </a:p>
+                  </a:txBody>
+                  <a:tcPr/>
+                </a:tc>
+                <a:tc>
+                  <a:txBody>
+                    <a:bodyPr/>
+                    <a:lstStyle/>
+                    <a:p>
+                      <a:r>
+                        <a:rPr lang="it-IT" dirty="0"/>
+                        <a:t>1,3</a:t>
+                      </a:r>
+                      <a:endParaRPr lang="en-GB" dirty="0"/>
+                    </a:p>
+                  </a:txBody>
+                  <a:tcPr/>
+                </a:tc>
+                <a:tc>
+                  <a:txBody>
+                    <a:bodyPr/>
+                    <a:lstStyle/>
+                    <a:p>
+                      <a:r>
+                        <a:rPr lang="it-IT" dirty="0"/>
+                        <a:t>2,2</a:t>
+                      </a:r>
+                      <a:endParaRPr lang="en-GB" dirty="0"/>
+                    </a:p>
+                  </a:txBody>
+                  <a:tcPr/>
+                </a:tc>
+                <a:tc>
+                  <a:txBody>
+                    <a:bodyPr/>
+                    <a:lstStyle/>
+                    <a:p>
+                      <a:r>
+                        <a:rPr lang="it-IT" dirty="0"/>
+                        <a:t>2,6</a:t>
+                      </a:r>
+                      <a:endParaRPr lang="en-GB" dirty="0"/>
+                    </a:p>
+                  </a:txBody>
+                  <a:tcPr/>
+                </a:tc>
+                <a:tc>
+                  <a:txBody>
+                    <a:bodyPr/>
+                    <a:lstStyle/>
+                    <a:p>
+                      <a:r>
+                        <a:rPr lang="it-IT" dirty="0"/>
+                        <a:t>3,7</a:t>
+                      </a:r>
+                      <a:endParaRPr lang="en-GB" dirty="0"/>
+                    </a:p>
+                  </a:txBody>
+                  <a:tcPr/>
+                </a:tc>
+                <a:extLst>
+                  <a:ext uri="{0D108BD9-81ED-4DB2-BD59-A6C34878D82A}">
+                    <a16:rowId xmlns:a16="http://schemas.microsoft.com/office/drawing/2014/main" val="369788681"/>
+                  </a:ext>
+                </a:extLst>
+              </a:tr>
+              <a:tr h="370840">
+                <a:tc>
+                  <a:txBody>
+                    <a:bodyPr/>
+                    <a:lstStyle/>
+                    <a:p>
+                      <a:r>
+                        <a:rPr lang="it-IT" dirty="0"/>
+                        <a:t>600</a:t>
+                      </a:r>
+                      <a:endParaRPr lang="en-GB" dirty="0"/>
+                    </a:p>
+                  </a:txBody>
+                  <a:tcPr/>
+                </a:tc>
+                <a:tc>
+                  <a:txBody>
+                    <a:bodyPr/>
+                    <a:lstStyle/>
+                    <a:p>
+                      <a:r>
+                        <a:rPr lang="it-IT" dirty="0"/>
+                        <a:t>558,3</a:t>
+                      </a:r>
+                      <a:endParaRPr lang="en-GB" dirty="0"/>
+                    </a:p>
+                  </a:txBody>
+                  <a:tcPr/>
+                </a:tc>
+                <a:tc>
+                  <a:txBody>
+                    <a:bodyPr/>
+                    <a:lstStyle/>
+                    <a:p>
+                      <a:r>
+                        <a:rPr lang="it-IT" dirty="0"/>
+                        <a:t>1,6</a:t>
+                      </a:r>
+                      <a:endParaRPr lang="en-GB" dirty="0"/>
+                    </a:p>
+                  </a:txBody>
+                  <a:tcPr/>
+                </a:tc>
+                <a:tc>
+                  <a:txBody>
+                    <a:bodyPr/>
+                    <a:lstStyle/>
+                    <a:p>
+                      <a:r>
+                        <a:rPr lang="it-IT" dirty="0"/>
+                        <a:t>1,5</a:t>
+                      </a:r>
+                      <a:endParaRPr lang="en-GB" dirty="0"/>
+                    </a:p>
+                  </a:txBody>
+                  <a:tcPr/>
+                </a:tc>
+                <a:tc>
+                  <a:txBody>
+                    <a:bodyPr/>
+                    <a:lstStyle/>
+                    <a:p>
+                      <a:r>
+                        <a:rPr lang="it-IT" dirty="0"/>
+                        <a:t>2,6</a:t>
+                      </a:r>
+                      <a:endParaRPr lang="en-GB" dirty="0"/>
+                    </a:p>
+                  </a:txBody>
+                  <a:tcPr/>
+                </a:tc>
+                <a:tc>
+                  <a:txBody>
+                    <a:bodyPr/>
+                    <a:lstStyle/>
+                    <a:p>
+                      <a:r>
+                        <a:rPr lang="it-IT" dirty="0"/>
+                        <a:t>2,8</a:t>
+                      </a:r>
+                      <a:endParaRPr lang="en-GB" dirty="0"/>
+                    </a:p>
+                  </a:txBody>
+                  <a:tcPr/>
+                </a:tc>
+                <a:tc>
+                  <a:txBody>
+                    <a:bodyPr/>
+                    <a:lstStyle/>
+                    <a:p>
+                      <a:r>
+                        <a:rPr lang="it-IT" dirty="0"/>
+                        <a:t>3,7</a:t>
+                      </a:r>
+                      <a:endParaRPr lang="en-GB" dirty="0"/>
+                    </a:p>
+                  </a:txBody>
+                  <a:tcPr/>
+                </a:tc>
+                <a:extLst>
+                  <a:ext uri="{0D108BD9-81ED-4DB2-BD59-A6C34878D82A}">
+                    <a16:rowId xmlns:a16="http://schemas.microsoft.com/office/drawing/2014/main" val="15991862"/>
+                  </a:ext>
+                </a:extLst>
+              </a:tr>
+              <a:tr h="370840">
+                <a:tc>
+                  <a:txBody>
+                    <a:bodyPr/>
+                    <a:lstStyle/>
+                    <a:p>
+                      <a:r>
+                        <a:rPr lang="it-IT" dirty="0"/>
+                        <a:t>1000</a:t>
+                      </a:r>
+                      <a:endParaRPr lang="en-GB" dirty="0"/>
+                    </a:p>
+                  </a:txBody>
+                  <a:tcPr/>
+                </a:tc>
+                <a:tc>
+                  <a:txBody>
+                    <a:bodyPr/>
+                    <a:lstStyle/>
+                    <a:p>
+                      <a:r>
+                        <a:rPr lang="it-IT" dirty="0"/>
+                        <a:t>866</a:t>
+                      </a:r>
+                      <a:endParaRPr lang="en-GB" dirty="0"/>
+                    </a:p>
+                  </a:txBody>
+                  <a:tcPr/>
+                </a:tc>
+                <a:tc>
+                  <a:txBody>
+                    <a:bodyPr/>
+                    <a:lstStyle/>
+                    <a:p>
+                      <a:r>
+                        <a:rPr lang="it-IT" dirty="0"/>
+                        <a:t>1,4</a:t>
+                      </a:r>
+                      <a:endParaRPr lang="en-GB" dirty="0"/>
+                    </a:p>
+                  </a:txBody>
+                  <a:tcPr/>
+                </a:tc>
+                <a:tc>
+                  <a:txBody>
+                    <a:bodyPr/>
+                    <a:lstStyle/>
+                    <a:p>
+                      <a:r>
+                        <a:rPr lang="it-IT" dirty="0"/>
+                        <a:t>1,2</a:t>
+                      </a:r>
+                      <a:endParaRPr lang="en-GB" dirty="0"/>
+                    </a:p>
+                  </a:txBody>
+                  <a:tcPr/>
+                </a:tc>
+                <a:tc>
+                  <a:txBody>
+                    <a:bodyPr/>
+                    <a:lstStyle/>
+                    <a:p>
+                      <a:r>
+                        <a:rPr lang="it-IT" dirty="0"/>
+                        <a:t>2,0</a:t>
+                      </a:r>
+                      <a:endParaRPr lang="en-GB" dirty="0"/>
+                    </a:p>
+                  </a:txBody>
+                  <a:tcPr/>
+                </a:tc>
+                <a:tc>
+                  <a:txBody>
+                    <a:bodyPr/>
+                    <a:lstStyle/>
+                    <a:p>
+                      <a:r>
+                        <a:rPr lang="it-IT" dirty="0"/>
+                        <a:t>2,3</a:t>
+                      </a:r>
+                      <a:endParaRPr lang="en-GB" dirty="0"/>
+                    </a:p>
+                  </a:txBody>
+                  <a:tcPr/>
+                </a:tc>
+                <a:tc>
+                  <a:txBody>
+                    <a:bodyPr/>
+                    <a:lstStyle/>
+                    <a:p>
+                      <a:r>
+                        <a:rPr lang="it-IT" dirty="0"/>
+                        <a:t>3,4</a:t>
+                      </a:r>
+                      <a:endParaRPr lang="en-GB" dirty="0"/>
+                    </a:p>
+                  </a:txBody>
+                  <a:tcPr/>
+                </a:tc>
+                <a:extLst>
+                  <a:ext uri="{0D108BD9-81ED-4DB2-BD59-A6C34878D82A}">
+                    <a16:rowId xmlns:a16="http://schemas.microsoft.com/office/drawing/2014/main" val="3095448716"/>
+                  </a:ext>
+                </a:extLst>
+              </a:tr>
+            </a:tbl>
+          </a:graphicData>
+        </a:graphic>
+      </p:graphicFrame>
+    </p:spTree>
+    <p:extLst>
+      <p:ext uri="{BB962C8B-B14F-4D97-AF65-F5344CB8AC3E}">
+        <p14:creationId xmlns:p14="http://schemas.microsoft.com/office/powerpoint/2010/main" val="3284269687"/>
+      </p:ext>
+    </p:extLst>
+  </p:cSld>
+  <p:clrMapOvr>
+    <a:masterClrMapping/>
+  </p:clrMapOvr>
+</p:sld>
+</file>
+
+<file path=ppt/slides/slide22.xml><?xml version="1.0" encoding="utf-8"?>
+<p:sld xmlns:a="http://schemas.openxmlformats.org/drawingml/2006/main" xmlns:r="http://schemas.openxmlformats.org/officeDocument/2006/relationships" xmlns:p="http://schemas.openxmlformats.org/presentationml/2006/main">
+  <p:cSld>
+    <p:spTree>
+      <p:nvGrpSpPr>
+        <p:cNvPr id="1" name="">
+          <a:extLst>
+            <a:ext uri="{FF2B5EF4-FFF2-40B4-BE49-F238E27FC236}">
+              <a16:creationId xmlns:a16="http://schemas.microsoft.com/office/drawing/2014/main" id="{DB1BD3F6-3E3A-31AF-0DB3-4FFFDBFF2059}"/>
+            </a:ext>
+          </a:extLst>
+        </p:cNvPr>
+        <p:cNvGrpSpPr/>
+        <p:nvPr/>
+      </p:nvGrpSpPr>
+      <p:grpSpPr>
+        <a:xfrm>
+          <a:off x="0" y="0"/>
+          <a:ext cx="0" cy="0"/>
+          <a:chOff x="0" y="0"/>
+          <a:chExt cx="0" cy="0"/>
+        </a:xfrm>
+      </p:grpSpPr>
+      <p:sp>
+        <p:nvSpPr>
+          <p:cNvPr id="2" name="Title 1">
+            <a:extLst>
+              <a:ext uri="{FF2B5EF4-FFF2-40B4-BE49-F238E27FC236}">
+                <a16:creationId xmlns:a16="http://schemas.microsoft.com/office/drawing/2014/main" id="{EBB0CC12-4353-9F7F-1210-571911191668}"/>
+              </a:ext>
+            </a:extLst>
+          </p:cNvPr>
+          <p:cNvSpPr>
+            <a:spLocks noGrp="1"/>
+          </p:cNvSpPr>
+          <p:nvPr>
+            <p:ph type="title"/>
+          </p:nvPr>
+        </p:nvSpPr>
+        <p:spPr/>
+        <p:txBody>
+          <a:bodyPr/>
+          <a:lstStyle/>
+          <a:p>
+            <a:r>
+              <a:rPr lang="it-IT" dirty="0"/>
+              <a:t>Risultati modello ONNX IN PYTHON</a:t>
+            </a:r>
+            <a:endParaRPr lang="en-GB" dirty="0"/>
+          </a:p>
+        </p:txBody>
+      </p:sp>
+      <p:graphicFrame>
+        <p:nvGraphicFramePr>
+          <p:cNvPr id="4" name="Content Placeholder 3">
+            <a:extLst>
+              <a:ext uri="{FF2B5EF4-FFF2-40B4-BE49-F238E27FC236}">
+                <a16:creationId xmlns:a16="http://schemas.microsoft.com/office/drawing/2014/main" id="{401D8BCD-4EE5-A96E-9908-C8D03930E924}"/>
+              </a:ext>
+            </a:extLst>
+          </p:cNvPr>
+          <p:cNvGraphicFramePr>
+            <a:graphicFrameLocks noGrp="1"/>
+          </p:cNvGraphicFramePr>
+          <p:nvPr>
+            <p:ph idx="1"/>
+            <p:extLst>
+              <p:ext uri="{D42A27DB-BD31-4B8C-83A1-F6EECF244321}">
+                <p14:modId xmlns:p14="http://schemas.microsoft.com/office/powerpoint/2010/main" val="1480696726"/>
+              </p:ext>
+            </p:extLst>
+          </p:nvPr>
+        </p:nvGraphicFramePr>
+        <p:xfrm>
+          <a:off x="684211" y="685800"/>
+          <a:ext cx="9639658" cy="2865120"/>
+        </p:xfrm>
+        <a:graphic>
+          <a:graphicData uri="http://schemas.openxmlformats.org/drawingml/2006/table">
+            <a:tbl>
+              <a:tblPr firstRow="1" bandRow="1">
+                <a:tableStyleId>{5C22544A-7EE6-4342-B048-85BDC9FD1C3A}</a:tableStyleId>
+              </a:tblPr>
+              <a:tblGrid>
+                <a:gridCol w="1377094">
+                  <a:extLst>
+                    <a:ext uri="{9D8B030D-6E8A-4147-A177-3AD203B41FA5}">
+                      <a16:colId xmlns:a16="http://schemas.microsoft.com/office/drawing/2014/main" val="4131664428"/>
+                    </a:ext>
+                  </a:extLst>
+                </a:gridCol>
+                <a:gridCol w="1377094">
+                  <a:extLst>
+                    <a:ext uri="{9D8B030D-6E8A-4147-A177-3AD203B41FA5}">
+                      <a16:colId xmlns:a16="http://schemas.microsoft.com/office/drawing/2014/main" val="2682047389"/>
+                    </a:ext>
+                  </a:extLst>
+                </a:gridCol>
+                <a:gridCol w="1377094">
+                  <a:extLst>
+                    <a:ext uri="{9D8B030D-6E8A-4147-A177-3AD203B41FA5}">
+                      <a16:colId xmlns:a16="http://schemas.microsoft.com/office/drawing/2014/main" val="560020995"/>
+                    </a:ext>
+                  </a:extLst>
+                </a:gridCol>
+                <a:gridCol w="1377094">
+                  <a:extLst>
+                    <a:ext uri="{9D8B030D-6E8A-4147-A177-3AD203B41FA5}">
+                      <a16:colId xmlns:a16="http://schemas.microsoft.com/office/drawing/2014/main" val="2200272610"/>
+                    </a:ext>
+                  </a:extLst>
+                </a:gridCol>
+                <a:gridCol w="1377094">
+                  <a:extLst>
+                    <a:ext uri="{9D8B030D-6E8A-4147-A177-3AD203B41FA5}">
+                      <a16:colId xmlns:a16="http://schemas.microsoft.com/office/drawing/2014/main" val="1594005505"/>
+                    </a:ext>
+                  </a:extLst>
+                </a:gridCol>
+                <a:gridCol w="1377094">
+                  <a:extLst>
+                    <a:ext uri="{9D8B030D-6E8A-4147-A177-3AD203B41FA5}">
+                      <a16:colId xmlns:a16="http://schemas.microsoft.com/office/drawing/2014/main" val="748764634"/>
+                    </a:ext>
+                  </a:extLst>
+                </a:gridCol>
+                <a:gridCol w="1377094">
+                  <a:extLst>
+                    <a:ext uri="{9D8B030D-6E8A-4147-A177-3AD203B41FA5}">
+                      <a16:colId xmlns:a16="http://schemas.microsoft.com/office/drawing/2014/main" val="3172487590"/>
+                    </a:ext>
+                  </a:extLst>
+                </a:gridCol>
+              </a:tblGrid>
+              <a:tr h="370840">
+                <a:tc>
+                  <a:txBody>
+                    <a:bodyPr/>
+                    <a:lstStyle/>
+                    <a:p>
+                      <a:r>
+                        <a:rPr lang="it-IT" dirty="0"/>
+                        <a:t>Target RPS</a:t>
+                      </a:r>
+                      <a:endParaRPr lang="en-GB" dirty="0"/>
+                    </a:p>
+                  </a:txBody>
+                  <a:tcPr/>
+                </a:tc>
+                <a:tc>
+                  <a:txBody>
+                    <a:bodyPr/>
+                    <a:lstStyle/>
+                    <a:p>
+                      <a:r>
+                        <a:rPr lang="it-IT" dirty="0"/>
+                        <a:t>RPS effettivi</a:t>
+                      </a:r>
+                      <a:endParaRPr lang="en-GB" dirty="0"/>
+                    </a:p>
+                  </a:txBody>
+                  <a:tcPr/>
+                </a:tc>
+                <a:tc>
+                  <a:txBody>
+                    <a:bodyPr/>
+                    <a:lstStyle/>
+                    <a:p>
+                      <a:r>
+                        <a:rPr lang="it-IT" dirty="0"/>
+                        <a:t>Media latenze (s)</a:t>
+                      </a:r>
+                      <a:endParaRPr lang="en-GB" dirty="0"/>
+                    </a:p>
+                  </a:txBody>
+                  <a:tcPr/>
+                </a:tc>
+                <a:tc>
+                  <a:txBody>
+                    <a:bodyPr/>
+                    <a:lstStyle/>
+                    <a:p>
+                      <a:r>
+                        <a:rPr lang="it-IT" dirty="0"/>
+                        <a:t>P50 (s)</a:t>
+                      </a:r>
+                      <a:endParaRPr lang="en-GB" dirty="0"/>
+                    </a:p>
+                  </a:txBody>
+                  <a:tcPr/>
+                </a:tc>
+                <a:tc>
+                  <a:txBody>
+                    <a:bodyPr/>
+                    <a:lstStyle/>
+                    <a:p>
+                      <a:r>
+                        <a:rPr lang="it-IT" dirty="0"/>
+                        <a:t>P(90) (s)</a:t>
+                      </a:r>
+                      <a:endParaRPr lang="en-GB" dirty="0"/>
+                    </a:p>
+                  </a:txBody>
+                  <a:tcPr/>
+                </a:tc>
+                <a:tc>
+                  <a:txBody>
+                    <a:bodyPr/>
+                    <a:lstStyle/>
+                    <a:p>
+                      <a:r>
+                        <a:rPr lang="it-IT" dirty="0"/>
+                        <a:t>P(95) (s)</a:t>
+                      </a:r>
+                      <a:endParaRPr lang="en-GB" dirty="0"/>
+                    </a:p>
+                  </a:txBody>
+                  <a:tcPr/>
+                </a:tc>
+                <a:tc>
+                  <a:txBody>
+                    <a:bodyPr/>
+                    <a:lstStyle/>
+                    <a:p>
+                      <a:r>
+                        <a:rPr lang="it-IT" dirty="0"/>
+                        <a:t>P(99) (s)</a:t>
+                      </a:r>
+                      <a:endParaRPr lang="en-GB" dirty="0"/>
+                    </a:p>
+                  </a:txBody>
+                  <a:tcPr/>
+                </a:tc>
+                <a:extLst>
+                  <a:ext uri="{0D108BD9-81ED-4DB2-BD59-A6C34878D82A}">
+                    <a16:rowId xmlns:a16="http://schemas.microsoft.com/office/drawing/2014/main" val="1019616449"/>
+                  </a:ext>
+                </a:extLst>
+              </a:tr>
+              <a:tr h="370840">
+                <a:tc>
+                  <a:txBody>
+                    <a:bodyPr/>
+                    <a:lstStyle/>
+                    <a:p>
+                      <a:r>
+                        <a:rPr lang="it-IT" dirty="0"/>
+                        <a:t>10</a:t>
+                      </a:r>
+                      <a:endParaRPr lang="en-GB" dirty="0"/>
+                    </a:p>
+                  </a:txBody>
+                  <a:tcPr/>
+                </a:tc>
+                <a:tc>
+                  <a:txBody>
+                    <a:bodyPr/>
+                    <a:lstStyle/>
+                    <a:p>
+                      <a:r>
+                        <a:rPr lang="it-IT" dirty="0"/>
+                        <a:t>9,9</a:t>
+                      </a:r>
+                      <a:endParaRPr lang="en-GB" dirty="0"/>
+                    </a:p>
+                  </a:txBody>
+                  <a:tcPr/>
+                </a:tc>
+                <a:tc>
+                  <a:txBody>
+                    <a:bodyPr/>
+                    <a:lstStyle/>
+                    <a:p>
+                      <a:r>
+                        <a:rPr lang="it-IT" dirty="0"/>
+                        <a:t>1,5</a:t>
+                      </a:r>
+                      <a:endParaRPr lang="en-GB" dirty="0"/>
+                    </a:p>
+                  </a:txBody>
+                  <a:tcPr/>
+                </a:tc>
+                <a:tc>
+                  <a:txBody>
+                    <a:bodyPr/>
+                    <a:lstStyle/>
+                    <a:p>
+                      <a:r>
+                        <a:rPr lang="it-IT" dirty="0"/>
+                        <a:t>1,5</a:t>
+                      </a:r>
+                      <a:endParaRPr lang="en-GB" dirty="0"/>
+                    </a:p>
+                  </a:txBody>
+                  <a:tcPr/>
+                </a:tc>
+                <a:tc>
+                  <a:txBody>
+                    <a:bodyPr/>
+                    <a:lstStyle/>
+                    <a:p>
+                      <a:r>
+                        <a:rPr lang="it-IT" dirty="0"/>
+                        <a:t>1,9</a:t>
+                      </a:r>
+                      <a:endParaRPr lang="en-GB" dirty="0"/>
+                    </a:p>
+                  </a:txBody>
+                  <a:tcPr/>
+                </a:tc>
+                <a:tc>
+                  <a:txBody>
+                    <a:bodyPr/>
+                    <a:lstStyle/>
+                    <a:p>
+                      <a:r>
+                        <a:rPr lang="it-IT" dirty="0"/>
+                        <a:t>2,1</a:t>
+                      </a:r>
+                      <a:endParaRPr lang="en-GB" dirty="0"/>
+                    </a:p>
+                  </a:txBody>
+                  <a:tcPr/>
+                </a:tc>
+                <a:tc>
+                  <a:txBody>
+                    <a:bodyPr/>
+                    <a:lstStyle/>
+                    <a:p>
+                      <a:r>
+                        <a:rPr lang="it-IT" dirty="0"/>
+                        <a:t>2,9</a:t>
+                      </a:r>
+                      <a:endParaRPr lang="en-GB" dirty="0"/>
+                    </a:p>
+                  </a:txBody>
+                  <a:tcPr/>
+                </a:tc>
+                <a:extLst>
+                  <a:ext uri="{0D108BD9-81ED-4DB2-BD59-A6C34878D82A}">
+                    <a16:rowId xmlns:a16="http://schemas.microsoft.com/office/drawing/2014/main" val="3033522304"/>
+                  </a:ext>
+                </a:extLst>
+              </a:tr>
+              <a:tr h="370840">
+                <a:tc>
+                  <a:txBody>
+                    <a:bodyPr/>
+                    <a:lstStyle/>
+                    <a:p>
+                      <a:r>
+                        <a:rPr lang="it-IT" dirty="0"/>
+                        <a:t>50</a:t>
+                      </a:r>
+                      <a:endParaRPr lang="en-GB" dirty="0"/>
+                    </a:p>
+                  </a:txBody>
+                  <a:tcPr/>
+                </a:tc>
+                <a:tc>
+                  <a:txBody>
+                    <a:bodyPr/>
+                    <a:lstStyle/>
+                    <a:p>
+                      <a:r>
+                        <a:rPr lang="it-IT" dirty="0"/>
+                        <a:t>49,9</a:t>
+                      </a:r>
+                      <a:endParaRPr lang="en-GB" dirty="0"/>
+                    </a:p>
+                  </a:txBody>
+                  <a:tcPr/>
+                </a:tc>
+                <a:tc>
+                  <a:txBody>
+                    <a:bodyPr/>
+                    <a:lstStyle/>
+                    <a:p>
+                      <a:r>
+                        <a:rPr lang="it-IT" dirty="0"/>
+                        <a:t>1,3</a:t>
+                      </a:r>
+                      <a:endParaRPr lang="en-GB" dirty="0"/>
+                    </a:p>
+                  </a:txBody>
+                  <a:tcPr/>
+                </a:tc>
+                <a:tc>
+                  <a:txBody>
+                    <a:bodyPr/>
+                    <a:lstStyle/>
+                    <a:p>
+                      <a:r>
+                        <a:rPr lang="it-IT" dirty="0"/>
+                        <a:t>1,2</a:t>
+                      </a:r>
+                      <a:endParaRPr lang="en-GB" dirty="0"/>
+                    </a:p>
+                  </a:txBody>
+                  <a:tcPr/>
+                </a:tc>
+                <a:tc>
+                  <a:txBody>
+                    <a:bodyPr/>
+                    <a:lstStyle/>
+                    <a:p>
+                      <a:r>
+                        <a:rPr lang="it-IT" dirty="0"/>
+                        <a:t>1,8</a:t>
+                      </a:r>
+                      <a:endParaRPr lang="en-GB" dirty="0"/>
+                    </a:p>
+                  </a:txBody>
+                  <a:tcPr/>
+                </a:tc>
+                <a:tc>
+                  <a:txBody>
+                    <a:bodyPr/>
+                    <a:lstStyle/>
+                    <a:p>
+                      <a:r>
+                        <a:rPr lang="it-IT" dirty="0"/>
+                        <a:t>2,0</a:t>
+                      </a:r>
+                      <a:endParaRPr lang="en-GB" dirty="0"/>
+                    </a:p>
+                  </a:txBody>
+                  <a:tcPr/>
+                </a:tc>
+                <a:tc>
+                  <a:txBody>
+                    <a:bodyPr/>
+                    <a:lstStyle/>
+                    <a:p>
+                      <a:r>
+                        <a:rPr lang="it-IT" dirty="0"/>
+                        <a:t>2,9</a:t>
+                      </a:r>
+                      <a:endParaRPr lang="en-GB" dirty="0"/>
+                    </a:p>
+                  </a:txBody>
+                  <a:tcPr/>
+                </a:tc>
+                <a:extLst>
+                  <a:ext uri="{0D108BD9-81ED-4DB2-BD59-A6C34878D82A}">
+                    <a16:rowId xmlns:a16="http://schemas.microsoft.com/office/drawing/2014/main" val="774249562"/>
+                  </a:ext>
+                </a:extLst>
+              </a:tr>
+              <a:tr h="370840">
+                <a:tc>
+                  <a:txBody>
+                    <a:bodyPr/>
+                    <a:lstStyle/>
+                    <a:p>
+                      <a:r>
+                        <a:rPr lang="it-IT" dirty="0"/>
+                        <a:t>150</a:t>
+                      </a:r>
+                      <a:endParaRPr lang="en-GB" dirty="0"/>
+                    </a:p>
+                  </a:txBody>
+                  <a:tcPr/>
+                </a:tc>
+                <a:tc>
+                  <a:txBody>
+                    <a:bodyPr/>
+                    <a:lstStyle/>
+                    <a:p>
+                      <a:r>
+                        <a:rPr lang="it-IT" dirty="0"/>
+                        <a:t>148,7</a:t>
+                      </a:r>
+                      <a:endParaRPr lang="en-GB" dirty="0"/>
+                    </a:p>
+                  </a:txBody>
+                  <a:tcPr/>
+                </a:tc>
+                <a:tc>
+                  <a:txBody>
+                    <a:bodyPr/>
+                    <a:lstStyle/>
+                    <a:p>
+                      <a:r>
+                        <a:rPr lang="it-IT" dirty="0"/>
+                        <a:t>1,2</a:t>
+                      </a:r>
+                      <a:endParaRPr lang="en-GB" dirty="0"/>
+                    </a:p>
+                  </a:txBody>
+                  <a:tcPr/>
+                </a:tc>
+                <a:tc>
+                  <a:txBody>
+                    <a:bodyPr/>
+                    <a:lstStyle/>
+                    <a:p>
+                      <a:r>
+                        <a:rPr lang="it-IT" dirty="0"/>
+                        <a:t>1,1</a:t>
+                      </a:r>
+                      <a:endParaRPr lang="en-GB" dirty="0"/>
+                    </a:p>
+                  </a:txBody>
+                  <a:tcPr/>
+                </a:tc>
+                <a:tc>
+                  <a:txBody>
+                    <a:bodyPr/>
+                    <a:lstStyle/>
+                    <a:p>
+                      <a:r>
+                        <a:rPr lang="it-IT" dirty="0"/>
+                        <a:t>1,9</a:t>
+                      </a:r>
+                      <a:endParaRPr lang="en-GB" dirty="0"/>
+                    </a:p>
+                  </a:txBody>
+                  <a:tcPr/>
+                </a:tc>
+                <a:tc>
+                  <a:txBody>
+                    <a:bodyPr/>
+                    <a:lstStyle/>
+                    <a:p>
+                      <a:r>
+                        <a:rPr lang="it-IT" dirty="0"/>
+                        <a:t>2,3</a:t>
+                      </a:r>
+                      <a:endParaRPr lang="en-GB" dirty="0"/>
+                    </a:p>
+                  </a:txBody>
+                  <a:tcPr/>
+                </a:tc>
+                <a:tc>
+                  <a:txBody>
+                    <a:bodyPr/>
+                    <a:lstStyle/>
+                    <a:p>
+                      <a:r>
+                        <a:rPr lang="it-IT" dirty="0"/>
+                        <a:t>3,6</a:t>
+                      </a:r>
+                      <a:endParaRPr lang="en-GB" dirty="0"/>
+                    </a:p>
+                  </a:txBody>
+                  <a:tcPr/>
+                </a:tc>
+                <a:extLst>
+                  <a:ext uri="{0D108BD9-81ED-4DB2-BD59-A6C34878D82A}">
+                    <a16:rowId xmlns:a16="http://schemas.microsoft.com/office/drawing/2014/main" val="3093664536"/>
+                  </a:ext>
+                </a:extLst>
+              </a:tr>
+              <a:tr h="370840">
+                <a:tc>
+                  <a:txBody>
+                    <a:bodyPr/>
+                    <a:lstStyle/>
+                    <a:p>
+                      <a:r>
+                        <a:rPr lang="it-IT" dirty="0"/>
+                        <a:t>300</a:t>
+                      </a:r>
+                      <a:endParaRPr lang="en-GB" dirty="0"/>
+                    </a:p>
+                  </a:txBody>
+                  <a:tcPr/>
+                </a:tc>
+                <a:tc>
+                  <a:txBody>
+                    <a:bodyPr/>
+                    <a:lstStyle/>
+                    <a:p>
+                      <a:r>
+                        <a:rPr lang="it-IT" dirty="0"/>
+                        <a:t>292,9</a:t>
+                      </a:r>
+                      <a:endParaRPr lang="en-GB" dirty="0"/>
+                    </a:p>
+                  </a:txBody>
+                  <a:tcPr/>
+                </a:tc>
+                <a:tc>
+                  <a:txBody>
+                    <a:bodyPr/>
+                    <a:lstStyle/>
+                    <a:p>
+                      <a:r>
+                        <a:rPr lang="it-IT" dirty="0"/>
+                        <a:t>1,4</a:t>
+                      </a:r>
+                      <a:endParaRPr lang="en-GB" dirty="0"/>
+                    </a:p>
+                  </a:txBody>
+                  <a:tcPr/>
+                </a:tc>
+                <a:tc>
+                  <a:txBody>
+                    <a:bodyPr/>
+                    <a:lstStyle/>
+                    <a:p>
+                      <a:r>
+                        <a:rPr lang="it-IT" dirty="0"/>
+                        <a:t>1,2</a:t>
+                      </a:r>
+                      <a:endParaRPr lang="en-GB" dirty="0"/>
+                    </a:p>
+                  </a:txBody>
+                  <a:tcPr/>
+                </a:tc>
+                <a:tc>
+                  <a:txBody>
+                    <a:bodyPr/>
+                    <a:lstStyle/>
+                    <a:p>
+                      <a:r>
+                        <a:rPr lang="it-IT" dirty="0"/>
+                        <a:t>2,1</a:t>
+                      </a:r>
+                      <a:endParaRPr lang="en-GB" dirty="0"/>
+                    </a:p>
+                  </a:txBody>
+                  <a:tcPr/>
+                </a:tc>
+                <a:tc>
+                  <a:txBody>
+                    <a:bodyPr/>
+                    <a:lstStyle/>
+                    <a:p>
+                      <a:r>
+                        <a:rPr lang="it-IT" dirty="0"/>
+                        <a:t>2,5</a:t>
+                      </a:r>
+                      <a:endParaRPr lang="en-GB" dirty="0"/>
+                    </a:p>
+                  </a:txBody>
+                  <a:tcPr/>
+                </a:tc>
+                <a:tc>
+                  <a:txBody>
+                    <a:bodyPr/>
+                    <a:lstStyle/>
+                    <a:p>
+                      <a:r>
+                        <a:rPr lang="it-IT" dirty="0"/>
+                        <a:t>3,5</a:t>
+                      </a:r>
+                      <a:endParaRPr lang="en-GB" dirty="0"/>
+                    </a:p>
+                  </a:txBody>
+                  <a:tcPr/>
+                </a:tc>
+                <a:extLst>
+                  <a:ext uri="{0D108BD9-81ED-4DB2-BD59-A6C34878D82A}">
+                    <a16:rowId xmlns:a16="http://schemas.microsoft.com/office/drawing/2014/main" val="369788681"/>
+                  </a:ext>
+                </a:extLst>
+              </a:tr>
+              <a:tr h="370840">
+                <a:tc>
+                  <a:txBody>
+                    <a:bodyPr/>
+                    <a:lstStyle/>
+                    <a:p>
+                      <a:r>
+                        <a:rPr lang="it-IT" dirty="0"/>
+                        <a:t>600</a:t>
+                      </a:r>
+                      <a:endParaRPr lang="en-GB" dirty="0"/>
+                    </a:p>
+                  </a:txBody>
+                  <a:tcPr/>
+                </a:tc>
+                <a:tc>
+                  <a:txBody>
+                    <a:bodyPr/>
+                    <a:lstStyle/>
+                    <a:p>
+                      <a:r>
+                        <a:rPr lang="it-IT" dirty="0"/>
+                        <a:t>553,6</a:t>
+                      </a:r>
+                      <a:endParaRPr lang="en-GB" dirty="0"/>
+                    </a:p>
+                  </a:txBody>
+                  <a:tcPr/>
+                </a:tc>
+                <a:tc>
+                  <a:txBody>
+                    <a:bodyPr/>
+                    <a:lstStyle/>
+                    <a:p>
+                      <a:r>
+                        <a:rPr lang="it-IT" dirty="0"/>
+                        <a:t>1,6</a:t>
+                      </a:r>
+                      <a:endParaRPr lang="en-GB" dirty="0"/>
+                    </a:p>
+                  </a:txBody>
+                  <a:tcPr/>
+                </a:tc>
+                <a:tc>
+                  <a:txBody>
+                    <a:bodyPr/>
+                    <a:lstStyle/>
+                    <a:p>
+                      <a:r>
+                        <a:rPr lang="it-IT" dirty="0"/>
+                        <a:t>1,5</a:t>
+                      </a:r>
+                      <a:endParaRPr lang="en-GB" dirty="0"/>
+                    </a:p>
+                  </a:txBody>
+                  <a:tcPr/>
+                </a:tc>
+                <a:tc>
+                  <a:txBody>
+                    <a:bodyPr/>
+                    <a:lstStyle/>
+                    <a:p>
+                      <a:r>
+                        <a:rPr lang="it-IT" dirty="0"/>
+                        <a:t>2,6</a:t>
+                      </a:r>
+                      <a:endParaRPr lang="en-GB" dirty="0"/>
+                    </a:p>
+                  </a:txBody>
+                  <a:tcPr/>
+                </a:tc>
+                <a:tc>
+                  <a:txBody>
+                    <a:bodyPr/>
+                    <a:lstStyle/>
+                    <a:p>
+                      <a:r>
+                        <a:rPr lang="it-IT" dirty="0"/>
+                        <a:t>2,8</a:t>
+                      </a:r>
+                      <a:endParaRPr lang="en-GB" dirty="0"/>
+                    </a:p>
+                  </a:txBody>
+                  <a:tcPr/>
+                </a:tc>
+                <a:tc>
+                  <a:txBody>
+                    <a:bodyPr/>
+                    <a:lstStyle/>
+                    <a:p>
+                      <a:r>
+                        <a:rPr lang="it-IT" dirty="0"/>
+                        <a:t>3,6</a:t>
+                      </a:r>
+                      <a:endParaRPr lang="en-GB" dirty="0"/>
+                    </a:p>
+                  </a:txBody>
+                  <a:tcPr/>
+                </a:tc>
+                <a:extLst>
+                  <a:ext uri="{0D108BD9-81ED-4DB2-BD59-A6C34878D82A}">
+                    <a16:rowId xmlns:a16="http://schemas.microsoft.com/office/drawing/2014/main" val="15991862"/>
+                  </a:ext>
+                </a:extLst>
+              </a:tr>
+              <a:tr h="370840">
+                <a:tc>
+                  <a:txBody>
+                    <a:bodyPr/>
+                    <a:lstStyle/>
+                    <a:p>
+                      <a:r>
+                        <a:rPr lang="it-IT" dirty="0"/>
+                        <a:t>1000</a:t>
+                      </a:r>
+                      <a:endParaRPr lang="en-GB" dirty="0"/>
+                    </a:p>
+                  </a:txBody>
+                  <a:tcPr/>
+                </a:tc>
+                <a:tc>
+                  <a:txBody>
+                    <a:bodyPr/>
+                    <a:lstStyle/>
+                    <a:p>
+                      <a:r>
+                        <a:rPr lang="it-IT" dirty="0"/>
+                        <a:t>866,8</a:t>
+                      </a:r>
+                      <a:endParaRPr lang="en-GB" dirty="0"/>
+                    </a:p>
+                  </a:txBody>
+                  <a:tcPr/>
+                </a:tc>
+                <a:tc>
+                  <a:txBody>
+                    <a:bodyPr/>
+                    <a:lstStyle/>
+                    <a:p>
+                      <a:r>
+                        <a:rPr lang="it-IT" dirty="0"/>
+                        <a:t>1,4</a:t>
+                      </a:r>
+                      <a:endParaRPr lang="en-GB" dirty="0"/>
+                    </a:p>
+                  </a:txBody>
+                  <a:tcPr/>
+                </a:tc>
+                <a:tc>
+                  <a:txBody>
+                    <a:bodyPr/>
+                    <a:lstStyle/>
+                    <a:p>
+                      <a:r>
+                        <a:rPr lang="it-IT" dirty="0"/>
+                        <a:t>1,1</a:t>
+                      </a:r>
+                      <a:endParaRPr lang="en-GB" dirty="0"/>
+                    </a:p>
+                  </a:txBody>
+                  <a:tcPr/>
+                </a:tc>
+                <a:tc>
+                  <a:txBody>
+                    <a:bodyPr/>
+                    <a:lstStyle/>
+                    <a:p>
+                      <a:r>
+                        <a:rPr lang="it-IT" dirty="0"/>
+                        <a:t>2,0</a:t>
+                      </a:r>
+                      <a:endParaRPr lang="en-GB" dirty="0"/>
+                    </a:p>
+                  </a:txBody>
+                  <a:tcPr/>
+                </a:tc>
+                <a:tc>
+                  <a:txBody>
+                    <a:bodyPr/>
+                    <a:lstStyle/>
+                    <a:p>
+                      <a:r>
+                        <a:rPr lang="it-IT" dirty="0"/>
+                        <a:t>2,3</a:t>
+                      </a:r>
+                      <a:endParaRPr lang="en-GB" dirty="0"/>
+                    </a:p>
+                  </a:txBody>
+                  <a:tcPr/>
+                </a:tc>
+                <a:tc>
+                  <a:txBody>
+                    <a:bodyPr/>
+                    <a:lstStyle/>
+                    <a:p>
+                      <a:r>
+                        <a:rPr lang="it-IT" dirty="0"/>
+                        <a:t>2,9</a:t>
+                      </a:r>
+                      <a:endParaRPr lang="en-GB" dirty="0"/>
+                    </a:p>
+                  </a:txBody>
+                  <a:tcPr/>
+                </a:tc>
+                <a:extLst>
+                  <a:ext uri="{0D108BD9-81ED-4DB2-BD59-A6C34878D82A}">
+                    <a16:rowId xmlns:a16="http://schemas.microsoft.com/office/drawing/2014/main" val="3095448716"/>
+                  </a:ext>
+                </a:extLst>
+              </a:tr>
+            </a:tbl>
+          </a:graphicData>
+        </a:graphic>
+      </p:graphicFrame>
+    </p:spTree>
+    <p:extLst>
+      <p:ext uri="{BB962C8B-B14F-4D97-AF65-F5344CB8AC3E}">
+        <p14:creationId xmlns:p14="http://schemas.microsoft.com/office/powerpoint/2010/main" val="2092261046"/>
       </p:ext>
     </p:extLst>
   </p:cSld>

</xml_diff>

<commit_message>
Update: adding Memory Impact logic
</commit_message>
<xml_diff>
--- a/Gsasrec.pptx
+++ b/Gsasrec.pptx
@@ -15028,7 +15028,7 @@
           <a:p>
             <a:fld id="{842CECD3-3569-4D6E-AA1B-67789CA6B4B3}" type="datetimeFigureOut">
               <a:rPr lang="en-GB" smtClean="0"/>
-              <a:t>15/05/2026</a:t>
+              <a:t>18/05/2026</a:t>
             </a:fld>
             <a:endParaRPr lang="en-GB"/>
           </a:p>
@@ -15464,7 +15464,7 @@
           <a:p>
             <a:fld id="{842CECD3-3569-4D6E-AA1B-67789CA6B4B3}" type="datetimeFigureOut">
               <a:rPr lang="en-GB" smtClean="0"/>
-              <a:t>15/05/2026</a:t>
+              <a:t>18/05/2026</a:t>
             </a:fld>
             <a:endParaRPr lang="en-GB"/>
           </a:p>
@@ -15714,7 +15714,7 @@
           <a:p>
             <a:fld id="{842CECD3-3569-4D6E-AA1B-67789CA6B4B3}" type="datetimeFigureOut">
               <a:rPr lang="en-GB" smtClean="0"/>
-              <a:t>15/05/2026</a:t>
+              <a:t>18/05/2026</a:t>
             </a:fld>
             <a:endParaRPr lang="en-GB"/>
           </a:p>
@@ -16022,7 +16022,7 @@
           <a:p>
             <a:fld id="{842CECD3-3569-4D6E-AA1B-67789CA6B4B3}" type="datetimeFigureOut">
               <a:rPr lang="en-GB" smtClean="0"/>
-              <a:t>15/05/2026</a:t>
+              <a:t>18/05/2026</a:t>
             </a:fld>
             <a:endParaRPr lang="en-GB"/>
           </a:p>
@@ -16340,7 +16340,7 @@
           <a:p>
             <a:fld id="{842CECD3-3569-4D6E-AA1B-67789CA6B4B3}" type="datetimeFigureOut">
               <a:rPr lang="en-GB" smtClean="0"/>
-              <a:t>15/05/2026</a:t>
+              <a:t>18/05/2026</a:t>
             </a:fld>
             <a:endParaRPr lang="en-GB"/>
           </a:p>
@@ -16642,7 +16642,7 @@
           <a:p>
             <a:fld id="{842CECD3-3569-4D6E-AA1B-67789CA6B4B3}" type="datetimeFigureOut">
               <a:rPr lang="en-GB" smtClean="0"/>
-              <a:t>15/05/2026</a:t>
+              <a:t>18/05/2026</a:t>
             </a:fld>
             <a:endParaRPr lang="en-GB"/>
           </a:p>
@@ -17009,7 +17009,7 @@
           <a:p>
             <a:fld id="{842CECD3-3569-4D6E-AA1B-67789CA6B4B3}" type="datetimeFigureOut">
               <a:rPr lang="en-GB" smtClean="0"/>
-              <a:t>15/05/2026</a:t>
+              <a:t>18/05/2026</a:t>
             </a:fld>
             <a:endParaRPr lang="en-GB"/>
           </a:p>
@@ -17183,7 +17183,7 @@
           <a:p>
             <a:fld id="{842CECD3-3569-4D6E-AA1B-67789CA6B4B3}" type="datetimeFigureOut">
               <a:rPr lang="en-GB" smtClean="0"/>
-              <a:t>15/05/2026</a:t>
+              <a:t>18/05/2026</a:t>
             </a:fld>
             <a:endParaRPr lang="en-GB"/>
           </a:p>
@@ -17363,7 +17363,7 @@
           <a:p>
             <a:fld id="{842CECD3-3569-4D6E-AA1B-67789CA6B4B3}" type="datetimeFigureOut">
               <a:rPr lang="en-GB" smtClean="0"/>
-              <a:t>15/05/2026</a:t>
+              <a:t>18/05/2026</a:t>
             </a:fld>
             <a:endParaRPr lang="en-GB"/>
           </a:p>
@@ -17533,7 +17533,7 @@
           <a:p>
             <a:fld id="{842CECD3-3569-4D6E-AA1B-67789CA6B4B3}" type="datetimeFigureOut">
               <a:rPr lang="en-GB" smtClean="0"/>
-              <a:t>15/05/2026</a:t>
+              <a:t>18/05/2026</a:t>
             </a:fld>
             <a:endParaRPr lang="en-GB"/>
           </a:p>
@@ -17783,7 +17783,7 @@
           <a:p>
             <a:fld id="{842CECD3-3569-4D6E-AA1B-67789CA6B4B3}" type="datetimeFigureOut">
               <a:rPr lang="en-GB" smtClean="0"/>
-              <a:t>15/05/2026</a:t>
+              <a:t>18/05/2026</a:t>
             </a:fld>
             <a:endParaRPr lang="en-GB"/>
           </a:p>
@@ -18019,7 +18019,7 @@
           <a:p>
             <a:fld id="{842CECD3-3569-4D6E-AA1B-67789CA6B4B3}" type="datetimeFigureOut">
               <a:rPr lang="en-GB" smtClean="0"/>
-              <a:t>15/05/2026</a:t>
+              <a:t>18/05/2026</a:t>
             </a:fld>
             <a:endParaRPr lang="en-GB"/>
           </a:p>
@@ -18401,7 +18401,7 @@
           <a:p>
             <a:fld id="{842CECD3-3569-4D6E-AA1B-67789CA6B4B3}" type="datetimeFigureOut">
               <a:rPr lang="en-GB" smtClean="0"/>
-              <a:t>15/05/2026</a:t>
+              <a:t>18/05/2026</a:t>
             </a:fld>
             <a:endParaRPr lang="en-GB"/>
           </a:p>
@@ -18519,7 +18519,7 @@
           <a:p>
             <a:fld id="{842CECD3-3569-4D6E-AA1B-67789CA6B4B3}" type="datetimeFigureOut">
               <a:rPr lang="en-GB" smtClean="0"/>
-              <a:t>15/05/2026</a:t>
+              <a:t>18/05/2026</a:t>
             </a:fld>
             <a:endParaRPr lang="en-GB"/>
           </a:p>
@@ -18614,7 +18614,7 @@
           <a:p>
             <a:fld id="{842CECD3-3569-4D6E-AA1B-67789CA6B4B3}" type="datetimeFigureOut">
               <a:rPr lang="en-GB" smtClean="0"/>
-              <a:t>15/05/2026</a:t>
+              <a:t>18/05/2026</a:t>
             </a:fld>
             <a:endParaRPr lang="en-GB"/>
           </a:p>
@@ -18869,7 +18869,7 @@
           <a:p>
             <a:fld id="{842CECD3-3569-4D6E-AA1B-67789CA6B4B3}" type="datetimeFigureOut">
               <a:rPr lang="en-GB" smtClean="0"/>
-              <a:t>15/05/2026</a:t>
+              <a:t>18/05/2026</a:t>
             </a:fld>
             <a:endParaRPr lang="en-GB"/>
           </a:p>
@@ -19152,7 +19152,7 @@
           <a:p>
             <a:fld id="{842CECD3-3569-4D6E-AA1B-67789CA6B4B3}" type="datetimeFigureOut">
               <a:rPr lang="en-GB" smtClean="0"/>
-              <a:t>15/05/2026</a:t>
+              <a:t>18/05/2026</a:t>
             </a:fld>
             <a:endParaRPr lang="en-GB"/>
           </a:p>
@@ -19558,7 +19558,7 @@
           <a:p>
             <a:fld id="{842CECD3-3569-4D6E-AA1B-67789CA6B4B3}" type="datetimeFigureOut">
               <a:rPr lang="en-GB" smtClean="0"/>
-              <a:t>15/05/2026</a:t>
+              <a:t>18/05/2026</a:t>
             </a:fld>
             <a:endParaRPr lang="en-GB"/>
           </a:p>
@@ -23573,7 +23573,7 @@
           <p:nvPr>
             <p:extLst>
               <p:ext uri="{D42A27DB-BD31-4B8C-83A1-F6EECF244321}">
-                <p14:modId xmlns:p14="http://schemas.microsoft.com/office/powerpoint/2010/main" val="4271203619"/>
+                <p14:modId xmlns:p14="http://schemas.microsoft.com/office/powerpoint/2010/main" val="2391205341"/>
               </p:ext>
             </p:extLst>
           </p:nvPr>
@@ -24275,7 +24275,7 @@
                     <a:p>
                       <a:r>
                         <a:rPr lang="it-IT" dirty="0"/>
-                        <a:t>1120</a:t>
+                        <a:t>1244</a:t>
                       </a:r>
                       <a:endParaRPr lang="en-GB" dirty="0"/>
                     </a:p>

</xml_diff>

<commit_message>
Try: use GPU on rust onnx endpoint
</commit_message>
<xml_diff>
--- a/Gsasrec.pptx
+++ b/Gsasrec.pptx
@@ -15028,7 +15028,7 @@
           <a:p>
             <a:fld id="{842CECD3-3569-4D6E-AA1B-67789CA6B4B3}" type="datetimeFigureOut">
               <a:rPr lang="en-GB" smtClean="0"/>
-              <a:t>18/05/2026</a:t>
+              <a:t>26/05/2026</a:t>
             </a:fld>
             <a:endParaRPr lang="en-GB"/>
           </a:p>
@@ -15464,7 +15464,7 @@
           <a:p>
             <a:fld id="{842CECD3-3569-4D6E-AA1B-67789CA6B4B3}" type="datetimeFigureOut">
               <a:rPr lang="en-GB" smtClean="0"/>
-              <a:t>18/05/2026</a:t>
+              <a:t>26/05/2026</a:t>
             </a:fld>
             <a:endParaRPr lang="en-GB"/>
           </a:p>
@@ -15714,7 +15714,7 @@
           <a:p>
             <a:fld id="{842CECD3-3569-4D6E-AA1B-67789CA6B4B3}" type="datetimeFigureOut">
               <a:rPr lang="en-GB" smtClean="0"/>
-              <a:t>18/05/2026</a:t>
+              <a:t>26/05/2026</a:t>
             </a:fld>
             <a:endParaRPr lang="en-GB"/>
           </a:p>
@@ -16022,7 +16022,7 @@
           <a:p>
             <a:fld id="{842CECD3-3569-4D6E-AA1B-67789CA6B4B3}" type="datetimeFigureOut">
               <a:rPr lang="en-GB" smtClean="0"/>
-              <a:t>18/05/2026</a:t>
+              <a:t>26/05/2026</a:t>
             </a:fld>
             <a:endParaRPr lang="en-GB"/>
           </a:p>
@@ -16340,7 +16340,7 @@
           <a:p>
             <a:fld id="{842CECD3-3569-4D6E-AA1B-67789CA6B4B3}" type="datetimeFigureOut">
               <a:rPr lang="en-GB" smtClean="0"/>
-              <a:t>18/05/2026</a:t>
+              <a:t>26/05/2026</a:t>
             </a:fld>
             <a:endParaRPr lang="en-GB"/>
           </a:p>
@@ -16642,7 +16642,7 @@
           <a:p>
             <a:fld id="{842CECD3-3569-4D6E-AA1B-67789CA6B4B3}" type="datetimeFigureOut">
               <a:rPr lang="en-GB" smtClean="0"/>
-              <a:t>18/05/2026</a:t>
+              <a:t>26/05/2026</a:t>
             </a:fld>
             <a:endParaRPr lang="en-GB"/>
           </a:p>
@@ -17009,7 +17009,7 @@
           <a:p>
             <a:fld id="{842CECD3-3569-4D6E-AA1B-67789CA6B4B3}" type="datetimeFigureOut">
               <a:rPr lang="en-GB" smtClean="0"/>
-              <a:t>18/05/2026</a:t>
+              <a:t>26/05/2026</a:t>
             </a:fld>
             <a:endParaRPr lang="en-GB"/>
           </a:p>
@@ -17183,7 +17183,7 @@
           <a:p>
             <a:fld id="{842CECD3-3569-4D6E-AA1B-67789CA6B4B3}" type="datetimeFigureOut">
               <a:rPr lang="en-GB" smtClean="0"/>
-              <a:t>18/05/2026</a:t>
+              <a:t>26/05/2026</a:t>
             </a:fld>
             <a:endParaRPr lang="en-GB"/>
           </a:p>
@@ -17363,7 +17363,7 @@
           <a:p>
             <a:fld id="{842CECD3-3569-4D6E-AA1B-67789CA6B4B3}" type="datetimeFigureOut">
               <a:rPr lang="en-GB" smtClean="0"/>
-              <a:t>18/05/2026</a:t>
+              <a:t>26/05/2026</a:t>
             </a:fld>
             <a:endParaRPr lang="en-GB"/>
           </a:p>
@@ -17533,7 +17533,7 @@
           <a:p>
             <a:fld id="{842CECD3-3569-4D6E-AA1B-67789CA6B4B3}" type="datetimeFigureOut">
               <a:rPr lang="en-GB" smtClean="0"/>
-              <a:t>18/05/2026</a:t>
+              <a:t>26/05/2026</a:t>
             </a:fld>
             <a:endParaRPr lang="en-GB"/>
           </a:p>
@@ -17783,7 +17783,7 @@
           <a:p>
             <a:fld id="{842CECD3-3569-4D6E-AA1B-67789CA6B4B3}" type="datetimeFigureOut">
               <a:rPr lang="en-GB" smtClean="0"/>
-              <a:t>18/05/2026</a:t>
+              <a:t>26/05/2026</a:t>
             </a:fld>
             <a:endParaRPr lang="en-GB"/>
           </a:p>
@@ -18019,7 +18019,7 @@
           <a:p>
             <a:fld id="{842CECD3-3569-4D6E-AA1B-67789CA6B4B3}" type="datetimeFigureOut">
               <a:rPr lang="en-GB" smtClean="0"/>
-              <a:t>18/05/2026</a:t>
+              <a:t>26/05/2026</a:t>
             </a:fld>
             <a:endParaRPr lang="en-GB"/>
           </a:p>
@@ -18401,7 +18401,7 @@
           <a:p>
             <a:fld id="{842CECD3-3569-4D6E-AA1B-67789CA6B4B3}" type="datetimeFigureOut">
               <a:rPr lang="en-GB" smtClean="0"/>
-              <a:t>18/05/2026</a:t>
+              <a:t>26/05/2026</a:t>
             </a:fld>
             <a:endParaRPr lang="en-GB"/>
           </a:p>
@@ -18519,7 +18519,7 @@
           <a:p>
             <a:fld id="{842CECD3-3569-4D6E-AA1B-67789CA6B4B3}" type="datetimeFigureOut">
               <a:rPr lang="en-GB" smtClean="0"/>
-              <a:t>18/05/2026</a:t>
+              <a:t>26/05/2026</a:t>
             </a:fld>
             <a:endParaRPr lang="en-GB"/>
           </a:p>
@@ -18614,7 +18614,7 @@
           <a:p>
             <a:fld id="{842CECD3-3569-4D6E-AA1B-67789CA6B4B3}" type="datetimeFigureOut">
               <a:rPr lang="en-GB" smtClean="0"/>
-              <a:t>18/05/2026</a:t>
+              <a:t>26/05/2026</a:t>
             </a:fld>
             <a:endParaRPr lang="en-GB"/>
           </a:p>
@@ -18869,7 +18869,7 @@
           <a:p>
             <a:fld id="{842CECD3-3569-4D6E-AA1B-67789CA6B4B3}" type="datetimeFigureOut">
               <a:rPr lang="en-GB" smtClean="0"/>
-              <a:t>18/05/2026</a:t>
+              <a:t>26/05/2026</a:t>
             </a:fld>
             <a:endParaRPr lang="en-GB"/>
           </a:p>
@@ -19152,7 +19152,7 @@
           <a:p>
             <a:fld id="{842CECD3-3569-4D6E-AA1B-67789CA6B4B3}" type="datetimeFigureOut">
               <a:rPr lang="en-GB" smtClean="0"/>
-              <a:t>18/05/2026</a:t>
+              <a:t>26/05/2026</a:t>
             </a:fld>
             <a:endParaRPr lang="en-GB"/>
           </a:p>
@@ -19558,7 +19558,7 @@
           <a:p>
             <a:fld id="{842CECD3-3569-4D6E-AA1B-67789CA6B4B3}" type="datetimeFigureOut">
               <a:rPr lang="en-GB" smtClean="0"/>
-              <a:t>18/05/2026</a:t>
+              <a:t>26/05/2026</a:t>
             </a:fld>
             <a:endParaRPr lang="en-GB"/>
           </a:p>

</xml_diff>